<commit_message>
Slide 1: show three feeds as separate phones side by side
Co-Authored-By: Claude Sonnet 5.5 <noreply@anthropic.com>
Claude-Session: https://claude.ai/code/session_0139kriXJ67p3UvpR2gsSR9G
</commit_message>
<xml_diff>
--- a/videoslides/cleverbox-tiktok-slides.pptx
+++ b/videoslides/cleverbox-tiktok-slides.pptx
@@ -2570,12 +2570,12 @@
         </p:nvSpPr>
         <p:spPr>
           <a:xfrm>
-            <a:off x="7772400" y="731520"/>
-            <a:ext cx="2377440" cy="5303520"/>
+            <a:off x="6583680" y="914400"/>
+            <a:ext cx="1554480" cy="4297680"/>
           </a:xfrm>
           <a:prstGeom prst="roundRect">
             <a:avLst>
-              <a:gd name="adj" fmla="val 11538"/>
+              <a:gd name="adj" fmla="val 17647"/>
             </a:avLst>
           </a:prstGeom>
           <a:solidFill>
@@ -2597,12 +2597,12 @@
         </p:nvSpPr>
         <p:spPr>
           <a:xfrm>
-            <a:off x="7863840" y="822960"/>
-            <a:ext cx="2194560" cy="5120640"/>
+            <a:off x="6675120" y="1005840"/>
+            <a:ext cx="1371600" cy="4114800"/>
           </a:xfrm>
           <a:prstGeom prst="roundRect">
             <a:avLst>
-              <a:gd name="adj" fmla="val 9167"/>
+              <a:gd name="adj" fmla="val 14667"/>
             </a:avLst>
           </a:prstGeom>
           <a:solidFill>
@@ -2624,15 +2624,747 @@
         </p:nvSpPr>
         <p:spPr>
           <a:xfrm>
-            <a:off x="8046720" y="1188720"/>
-            <a:ext cx="1828800" cy="4389120"/>
+            <a:off x="6766560" y="1188720"/>
+            <a:ext cx="1188720" cy="1097280"/>
           </a:xfrm>
           <a:prstGeom prst="roundRect">
             <a:avLst>
-              <a:gd name="adj" fmla="val 6000"/>
+              <a:gd name="adj" fmla="val 10000"/>
             </a:avLst>
           </a:prstGeom>
           <a:solidFill>
+            <a:srgbClr val="DDF3B8"/>
+          </a:solidFill>
+          <a:ln w="12700">
+            <a:solidFill>
+              <a:srgbClr val="DDF3B8"/>
+            </a:solidFill>
+            <a:prstDash val="solid"/>
+          </a:ln>
+        </p:spPr>
+      </p:sp>
+      <p:sp>
+        <p:nvSpPr>
+          <p:cNvPr id="9" name="Shape 6"/>
+          <p:cNvSpPr/>
+          <p:nvPr/>
+        </p:nvSpPr>
+        <p:spPr>
+          <a:xfrm>
+            <a:off x="6903720" y="1353312"/>
+            <a:ext cx="365760" cy="329184"/>
+          </a:xfrm>
+          <a:prstGeom prst="heart">
+            <a:avLst/>
+          </a:prstGeom>
+          <a:solidFill>
+            <a:srgbClr val="26720A"/>
+          </a:solidFill>
+          <a:ln w="12700">
+            <a:solidFill>
+              <a:srgbClr val="26720A"/>
+            </a:solidFill>
+            <a:prstDash val="solid"/>
+          </a:ln>
+        </p:spPr>
+      </p:sp>
+      <p:sp>
+        <p:nvSpPr>
+          <p:cNvPr id="10" name="Text 7"/>
+          <p:cNvSpPr txBox="1"/>
+          <p:nvPr/>
+        </p:nvSpPr>
+        <p:spPr>
+          <a:xfrm>
+            <a:off x="6858000" y="1755648"/>
+            <a:ext cx="1005840" cy="457200"/>
+          </a:xfrm>
+          <a:prstGeom prst="rect">
+            <a:avLst/>
+          </a:prstGeom>
+          <a:noFill/>
+          <a:ln/>
+        </p:spPr>
+        <p:txBody>
+          <a:bodyPr wrap="square" lIns="0" tIns="0" rIns="0" bIns="0" rtlCol="0" anchor="ctr"/>
+          <a:lstStyle/>
+          <a:p>
+            <a:pPr indent="0" marL="0">
+              <a:buNone/>
+            </a:pPr>
+            <a:r>
+              <a:rPr lang="en-US" sz="1200" b="1" dirty="0">
+                <a:solidFill>
+                  <a:srgbClr val="0E1F0C"/>
+                </a:solidFill>
+                <a:latin typeface="Poppins" pitchFamily="34" charset="0"/>
+                <a:ea typeface="Poppins" pitchFamily="34" charset="-122"/>
+                <a:cs typeface="Poppins" pitchFamily="34" charset="-120"/>
+              </a:rPr>
+              <a:t>Tanz-Challenge</a:t>
+            </a:r>
+            <a:endParaRPr lang="en-US" sz="1200" dirty="0"/>
+          </a:p>
+        </p:txBody>
+      </p:sp>
+      <p:sp>
+        <p:nvSpPr>
+          <p:cNvPr id="11" name="Shape 8"/>
+          <p:cNvSpPr/>
+          <p:nvPr/>
+        </p:nvSpPr>
+        <p:spPr>
+          <a:xfrm>
+            <a:off x="6766560" y="2468880"/>
+            <a:ext cx="1188720" cy="1097280"/>
+          </a:xfrm>
+          <a:prstGeom prst="roundRect">
+            <a:avLst>
+              <a:gd name="adj" fmla="val 10000"/>
+            </a:avLst>
+          </a:prstGeom>
+          <a:solidFill>
+            <a:srgbClr val="DDF3B8"/>
+          </a:solidFill>
+          <a:ln w="12700">
+            <a:solidFill>
+              <a:srgbClr val="DDF3B8"/>
+            </a:solidFill>
+            <a:prstDash val="solid"/>
+          </a:ln>
+        </p:spPr>
+      </p:sp>
+      <p:sp>
+        <p:nvSpPr>
+          <p:cNvPr id="12" name="Shape 9"/>
+          <p:cNvSpPr/>
+          <p:nvPr/>
+        </p:nvSpPr>
+        <p:spPr>
+          <a:xfrm>
+            <a:off x="6903720" y="2633472"/>
+            <a:ext cx="365760" cy="329184"/>
+          </a:xfrm>
+          <a:prstGeom prst="heart">
+            <a:avLst/>
+          </a:prstGeom>
+          <a:solidFill>
+            <a:srgbClr val="26720A"/>
+          </a:solidFill>
+          <a:ln w="12700">
+            <a:solidFill>
+              <a:srgbClr val="26720A"/>
+            </a:solidFill>
+            <a:prstDash val="solid"/>
+          </a:ln>
+        </p:spPr>
+      </p:sp>
+      <p:sp>
+        <p:nvSpPr>
+          <p:cNvPr id="13" name="Text 10"/>
+          <p:cNvSpPr txBox="1"/>
+          <p:nvPr/>
+        </p:nvSpPr>
+        <p:spPr>
+          <a:xfrm>
+            <a:off x="6858000" y="3035808"/>
+            <a:ext cx="1005840" cy="457200"/>
+          </a:xfrm>
+          <a:prstGeom prst="rect">
+            <a:avLst/>
+          </a:prstGeom>
+          <a:noFill/>
+          <a:ln/>
+        </p:spPr>
+        <p:txBody>
+          <a:bodyPr wrap="square" lIns="0" tIns="0" rIns="0" bIns="0" rtlCol="0" anchor="ctr"/>
+          <a:lstStyle/>
+          <a:p>
+            <a:pPr indent="0" marL="0">
+              <a:buNone/>
+            </a:pPr>
+            <a:r>
+              <a:rPr lang="en-US" sz="1200" b="1" dirty="0">
+                <a:solidFill>
+                  <a:srgbClr val="0E1F0C"/>
+                </a:solidFill>
+                <a:latin typeface="Poppins" pitchFamily="34" charset="0"/>
+                <a:ea typeface="Poppins" pitchFamily="34" charset="-122"/>
+                <a:cs typeface="Poppins" pitchFamily="34" charset="-120"/>
+              </a:rPr>
+              <a:t>Choreo lernen</a:t>
+            </a:r>
+            <a:endParaRPr lang="en-US" sz="1200" dirty="0"/>
+          </a:p>
+        </p:txBody>
+      </p:sp>
+      <p:sp>
+        <p:nvSpPr>
+          <p:cNvPr id="14" name="Shape 11"/>
+          <p:cNvSpPr/>
+          <p:nvPr/>
+        </p:nvSpPr>
+        <p:spPr>
+          <a:xfrm>
+            <a:off x="6766560" y="3749040"/>
+            <a:ext cx="1188720" cy="1097280"/>
+          </a:xfrm>
+          <a:prstGeom prst="roundRect">
+            <a:avLst>
+              <a:gd name="adj" fmla="val 10000"/>
+            </a:avLst>
+          </a:prstGeom>
+          <a:solidFill>
+            <a:srgbClr val="DDF3B8"/>
+          </a:solidFill>
+          <a:ln w="12700">
+            <a:solidFill>
+              <a:srgbClr val="DDF3B8"/>
+            </a:solidFill>
+            <a:prstDash val="solid"/>
+          </a:ln>
+        </p:spPr>
+      </p:sp>
+      <p:sp>
+        <p:nvSpPr>
+          <p:cNvPr id="15" name="Shape 12"/>
+          <p:cNvSpPr/>
+          <p:nvPr/>
+        </p:nvSpPr>
+        <p:spPr>
+          <a:xfrm>
+            <a:off x="6903720" y="3913632"/>
+            <a:ext cx="365760" cy="329184"/>
+          </a:xfrm>
+          <a:prstGeom prst="heart">
+            <a:avLst/>
+          </a:prstGeom>
+          <a:solidFill>
+            <a:srgbClr val="26720A"/>
+          </a:solidFill>
+          <a:ln w="12700">
+            <a:solidFill>
+              <a:srgbClr val="26720A"/>
+            </a:solidFill>
+            <a:prstDash val="solid"/>
+          </a:ln>
+        </p:spPr>
+      </p:sp>
+      <p:sp>
+        <p:nvSpPr>
+          <p:cNvPr id="16" name="Text 13"/>
+          <p:cNvSpPr txBox="1"/>
+          <p:nvPr/>
+        </p:nvSpPr>
+        <p:spPr>
+          <a:xfrm>
+            <a:off x="6858000" y="4315968"/>
+            <a:ext cx="1005840" cy="457200"/>
+          </a:xfrm>
+          <a:prstGeom prst="rect">
+            <a:avLst/>
+          </a:prstGeom>
+          <a:noFill/>
+          <a:ln/>
+        </p:spPr>
+        <p:txBody>
+          <a:bodyPr wrap="square" lIns="0" tIns="0" rIns="0" bIns="0" rtlCol="0" anchor="ctr"/>
+          <a:lstStyle/>
+          <a:p>
+            <a:pPr indent="0" marL="0">
+              <a:buNone/>
+            </a:pPr>
+            <a:r>
+              <a:rPr lang="en-US" sz="1200" b="1" dirty="0">
+                <a:solidFill>
+                  <a:srgbClr val="0E1F0C"/>
+                </a:solidFill>
+                <a:latin typeface="Poppins" pitchFamily="34" charset="0"/>
+                <a:ea typeface="Poppins" pitchFamily="34" charset="-122"/>
+                <a:cs typeface="Poppins" pitchFamily="34" charset="-120"/>
+              </a:rPr>
+              <a:t>Duett-Tanz</a:t>
+            </a:r>
+            <a:endParaRPr lang="en-US" sz="1200" dirty="0"/>
+          </a:p>
+        </p:txBody>
+      </p:sp>
+      <p:sp>
+        <p:nvSpPr>
+          <p:cNvPr id="17" name="Text 14"/>
+          <p:cNvSpPr txBox="1"/>
+          <p:nvPr/>
+        </p:nvSpPr>
+        <p:spPr>
+          <a:xfrm>
+            <a:off x="6492240" y="5349240"/>
+            <a:ext cx="1737360" cy="365760"/>
+          </a:xfrm>
+          <a:prstGeom prst="rect">
+            <a:avLst/>
+          </a:prstGeom>
+          <a:noFill/>
+          <a:ln/>
+        </p:spPr>
+        <p:txBody>
+          <a:bodyPr wrap="square" lIns="0" tIns="0" rIns="0" bIns="0" rtlCol="0" anchor="t"/>
+          <a:lstStyle/>
+          <a:p>
+            <a:pPr algn="ctr" indent="0" marL="0">
+              <a:buNone/>
+            </a:pPr>
+            <a:r>
+              <a:rPr lang="en-US" sz="1600" b="1" dirty="0">
+                <a:solidFill>
+                  <a:srgbClr val="0E1F0C"/>
+                </a:solidFill>
+                <a:latin typeface="Poppins" pitchFamily="34" charset="0"/>
+                <a:ea typeface="Poppins" pitchFamily="34" charset="-122"/>
+                <a:cs typeface="Poppins" pitchFamily="34" charset="-120"/>
+              </a:rPr>
+              <a:t>Lenas Feed</a:t>
+            </a:r>
+            <a:endParaRPr lang="en-US" sz="1600" dirty="0"/>
+          </a:p>
+        </p:txBody>
+      </p:sp>
+      <p:sp>
+        <p:nvSpPr>
+          <p:cNvPr id="18" name="Shape 15"/>
+          <p:cNvSpPr/>
+          <p:nvPr/>
+        </p:nvSpPr>
+        <p:spPr>
+          <a:xfrm>
+            <a:off x="8275320" y="914400"/>
+            <a:ext cx="1554480" cy="4297680"/>
+          </a:xfrm>
+          <a:prstGeom prst="roundRect">
+            <a:avLst>
+              <a:gd name="adj" fmla="val 17647"/>
+            </a:avLst>
+          </a:prstGeom>
+          <a:solidFill>
+            <a:srgbClr val="12301A"/>
+          </a:solidFill>
+          <a:ln w="12700">
+            <a:solidFill>
+              <a:srgbClr val="12301A"/>
+            </a:solidFill>
+            <a:prstDash val="solid"/>
+          </a:ln>
+        </p:spPr>
+      </p:sp>
+      <p:sp>
+        <p:nvSpPr>
+          <p:cNvPr id="19" name="Shape 16"/>
+          <p:cNvSpPr/>
+          <p:nvPr/>
+        </p:nvSpPr>
+        <p:spPr>
+          <a:xfrm>
+            <a:off x="8366760" y="1005840"/>
+            <a:ext cx="1371600" cy="4114800"/>
+          </a:xfrm>
+          <a:prstGeom prst="roundRect">
+            <a:avLst>
+              <a:gd name="adj" fmla="val 14667"/>
+            </a:avLst>
+          </a:prstGeom>
+          <a:solidFill>
+            <a:srgbClr val="FBFFF4"/>
+          </a:solidFill>
+          <a:ln w="12700">
+            <a:solidFill>
+              <a:srgbClr val="FBFFF4"/>
+            </a:solidFill>
+            <a:prstDash val="solid"/>
+          </a:ln>
+        </p:spPr>
+      </p:sp>
+      <p:sp>
+        <p:nvSpPr>
+          <p:cNvPr id="20" name="Shape 17"/>
+          <p:cNvSpPr/>
+          <p:nvPr/>
+        </p:nvSpPr>
+        <p:spPr>
+          <a:xfrm>
+            <a:off x="8458200" y="1188720"/>
+            <a:ext cx="1188720" cy="1097280"/>
+          </a:xfrm>
+          <a:prstGeom prst="roundRect">
+            <a:avLst>
+              <a:gd name="adj" fmla="val 10000"/>
+            </a:avLst>
+          </a:prstGeom>
+          <a:solidFill>
+            <a:srgbClr val="DDF3B8"/>
+          </a:solidFill>
+          <a:ln w="12700">
+            <a:solidFill>
+              <a:srgbClr val="DDF3B8"/>
+            </a:solidFill>
+            <a:prstDash val="solid"/>
+          </a:ln>
+        </p:spPr>
+      </p:sp>
+      <p:sp>
+        <p:nvSpPr>
+          <p:cNvPr id="21" name="Shape 18"/>
+          <p:cNvSpPr/>
+          <p:nvPr/>
+        </p:nvSpPr>
+        <p:spPr>
+          <a:xfrm>
+            <a:off x="8595360" y="1335024"/>
+            <a:ext cx="365760" cy="365760"/>
+          </a:xfrm>
+          <a:prstGeom prst="ellipse">
+            <a:avLst/>
+          </a:prstGeom>
+          <a:solidFill>
+            <a:srgbClr val="26720A"/>
+          </a:solidFill>
+          <a:ln w="12700">
+            <a:solidFill>
+              <a:srgbClr val="26720A"/>
+            </a:solidFill>
+            <a:prstDash val="solid"/>
+          </a:ln>
+        </p:spPr>
+      </p:sp>
+      <p:sp>
+        <p:nvSpPr>
+          <p:cNvPr id="22" name="Text 19"/>
+          <p:cNvSpPr txBox="1"/>
+          <p:nvPr/>
+        </p:nvSpPr>
+        <p:spPr>
+          <a:xfrm>
+            <a:off x="8549640" y="1755648"/>
+            <a:ext cx="1005840" cy="457200"/>
+          </a:xfrm>
+          <a:prstGeom prst="rect">
+            <a:avLst/>
+          </a:prstGeom>
+          <a:noFill/>
+          <a:ln/>
+        </p:spPr>
+        <p:txBody>
+          <a:bodyPr wrap="square" lIns="0" tIns="0" rIns="0" bIns="0" rtlCol="0" anchor="ctr"/>
+          <a:lstStyle/>
+          <a:p>
+            <a:pPr indent="0" marL="0">
+              <a:buNone/>
+            </a:pPr>
+            <a:r>
+              <a:rPr lang="en-US" sz="1200" b="1" dirty="0">
+                <a:solidFill>
+                  <a:srgbClr val="0E1F0C"/>
+                </a:solidFill>
+                <a:latin typeface="Poppins" pitchFamily="34" charset="0"/>
+                <a:ea typeface="Poppins" pitchFamily="34" charset="-122"/>
+                <a:cs typeface="Poppins" pitchFamily="34" charset="-120"/>
+              </a:rPr>
+              <a:t>Elfmeter-Tricks</a:t>
+            </a:r>
+            <a:endParaRPr lang="en-US" sz="1200" dirty="0"/>
+          </a:p>
+        </p:txBody>
+      </p:sp>
+      <p:sp>
+        <p:nvSpPr>
+          <p:cNvPr id="23" name="Shape 20"/>
+          <p:cNvSpPr/>
+          <p:nvPr/>
+        </p:nvSpPr>
+        <p:spPr>
+          <a:xfrm>
+            <a:off x="8458200" y="2468880"/>
+            <a:ext cx="1188720" cy="1097280"/>
+          </a:xfrm>
+          <a:prstGeom prst="roundRect">
+            <a:avLst>
+              <a:gd name="adj" fmla="val 10000"/>
+            </a:avLst>
+          </a:prstGeom>
+          <a:solidFill>
+            <a:srgbClr val="DDF3B8"/>
+          </a:solidFill>
+          <a:ln w="12700">
+            <a:solidFill>
+              <a:srgbClr val="DDF3B8"/>
+            </a:solidFill>
+            <a:prstDash val="solid"/>
+          </a:ln>
+        </p:spPr>
+      </p:sp>
+      <p:sp>
+        <p:nvSpPr>
+          <p:cNvPr id="24" name="Shape 21"/>
+          <p:cNvSpPr/>
+          <p:nvPr/>
+        </p:nvSpPr>
+        <p:spPr>
+          <a:xfrm>
+            <a:off x="8595360" y="2615184"/>
+            <a:ext cx="365760" cy="365760"/>
+          </a:xfrm>
+          <a:prstGeom prst="ellipse">
+            <a:avLst/>
+          </a:prstGeom>
+          <a:solidFill>
+            <a:srgbClr val="26720A"/>
+          </a:solidFill>
+          <a:ln w="12700">
+            <a:solidFill>
+              <a:srgbClr val="26720A"/>
+            </a:solidFill>
+            <a:prstDash val="solid"/>
+          </a:ln>
+        </p:spPr>
+      </p:sp>
+      <p:sp>
+        <p:nvSpPr>
+          <p:cNvPr id="25" name="Text 22"/>
+          <p:cNvSpPr txBox="1"/>
+          <p:nvPr/>
+        </p:nvSpPr>
+        <p:spPr>
+          <a:xfrm>
+            <a:off x="8549640" y="3035808"/>
+            <a:ext cx="1005840" cy="457200"/>
+          </a:xfrm>
+          <a:prstGeom prst="rect">
+            <a:avLst/>
+          </a:prstGeom>
+          <a:noFill/>
+          <a:ln/>
+        </p:spPr>
+        <p:txBody>
+          <a:bodyPr wrap="square" lIns="0" tIns="0" rIns="0" bIns="0" rtlCol="0" anchor="ctr"/>
+          <a:lstStyle/>
+          <a:p>
+            <a:pPr indent="0" marL="0">
+              <a:buNone/>
+            </a:pPr>
+            <a:r>
+              <a:rPr lang="en-US" sz="1200" b="1" dirty="0">
+                <a:solidFill>
+                  <a:srgbClr val="0E1F0C"/>
+                </a:solidFill>
+                <a:latin typeface="Poppins" pitchFamily="34" charset="0"/>
+                <a:ea typeface="Poppins" pitchFamily="34" charset="-122"/>
+                <a:cs typeface="Poppins" pitchFamily="34" charset="-120"/>
+              </a:rPr>
+              <a:t>Tor des Monats</a:t>
+            </a:r>
+            <a:endParaRPr lang="en-US" sz="1200" dirty="0"/>
+          </a:p>
+        </p:txBody>
+      </p:sp>
+      <p:sp>
+        <p:nvSpPr>
+          <p:cNvPr id="26" name="Shape 23"/>
+          <p:cNvSpPr/>
+          <p:nvPr/>
+        </p:nvSpPr>
+        <p:spPr>
+          <a:xfrm>
+            <a:off x="8458200" y="3749040"/>
+            <a:ext cx="1188720" cy="1097280"/>
+          </a:xfrm>
+          <a:prstGeom prst="roundRect">
+            <a:avLst>
+              <a:gd name="adj" fmla="val 10000"/>
+            </a:avLst>
+          </a:prstGeom>
+          <a:solidFill>
+            <a:srgbClr val="DDF3B8"/>
+          </a:solidFill>
+          <a:ln w="12700">
+            <a:solidFill>
+              <a:srgbClr val="DDF3B8"/>
+            </a:solidFill>
+            <a:prstDash val="solid"/>
+          </a:ln>
+        </p:spPr>
+      </p:sp>
+      <p:sp>
+        <p:nvSpPr>
+          <p:cNvPr id="27" name="Shape 24"/>
+          <p:cNvSpPr/>
+          <p:nvPr/>
+        </p:nvSpPr>
+        <p:spPr>
+          <a:xfrm>
+            <a:off x="8595360" y="3895344"/>
+            <a:ext cx="365760" cy="365760"/>
+          </a:xfrm>
+          <a:prstGeom prst="ellipse">
+            <a:avLst/>
+          </a:prstGeom>
+          <a:solidFill>
+            <a:srgbClr val="26720A"/>
+          </a:solidFill>
+          <a:ln w="12700">
+            <a:solidFill>
+              <a:srgbClr val="26720A"/>
+            </a:solidFill>
+            <a:prstDash val="solid"/>
+          </a:ln>
+        </p:spPr>
+      </p:sp>
+      <p:sp>
+        <p:nvSpPr>
+          <p:cNvPr id="28" name="Text 25"/>
+          <p:cNvSpPr txBox="1"/>
+          <p:nvPr/>
+        </p:nvSpPr>
+        <p:spPr>
+          <a:xfrm>
+            <a:off x="8549640" y="4315968"/>
+            <a:ext cx="1005840" cy="457200"/>
+          </a:xfrm>
+          <a:prstGeom prst="rect">
+            <a:avLst/>
+          </a:prstGeom>
+          <a:noFill/>
+          <a:ln/>
+        </p:spPr>
+        <p:txBody>
+          <a:bodyPr wrap="square" lIns="0" tIns="0" rIns="0" bIns="0" rtlCol="0" anchor="ctr"/>
+          <a:lstStyle/>
+          <a:p>
+            <a:pPr indent="0" marL="0">
+              <a:buNone/>
+            </a:pPr>
+            <a:r>
+              <a:rPr lang="en-US" sz="1200" b="1" dirty="0">
+                <a:solidFill>
+                  <a:srgbClr val="0E1F0C"/>
+                </a:solidFill>
+                <a:latin typeface="Poppins" pitchFamily="34" charset="0"/>
+                <a:ea typeface="Poppins" pitchFamily="34" charset="-122"/>
+                <a:cs typeface="Poppins" pitchFamily="34" charset="-120"/>
+              </a:rPr>
+              <a:t>Highlights</a:t>
+            </a:r>
+            <a:endParaRPr lang="en-US" sz="1200" dirty="0"/>
+          </a:p>
+        </p:txBody>
+      </p:sp>
+      <p:sp>
+        <p:nvSpPr>
+          <p:cNvPr id="29" name="Text 26"/>
+          <p:cNvSpPr txBox="1"/>
+          <p:nvPr/>
+        </p:nvSpPr>
+        <p:spPr>
+          <a:xfrm>
+            <a:off x="8183880" y="5349240"/>
+            <a:ext cx="1737360" cy="365760"/>
+          </a:xfrm>
+          <a:prstGeom prst="rect">
+            <a:avLst/>
+          </a:prstGeom>
+          <a:noFill/>
+          <a:ln/>
+        </p:spPr>
+        <p:txBody>
+          <a:bodyPr wrap="square" lIns="0" tIns="0" rIns="0" bIns="0" rtlCol="0" anchor="t"/>
+          <a:lstStyle/>
+          <a:p>
+            <a:pPr algn="ctr" indent="0" marL="0">
+              <a:buNone/>
+            </a:pPr>
+            <a:r>
+              <a:rPr lang="en-US" sz="1600" b="1" dirty="0">
+                <a:solidFill>
+                  <a:srgbClr val="0E1F0C"/>
+                </a:solidFill>
+                <a:latin typeface="Poppins" pitchFamily="34" charset="0"/>
+                <a:ea typeface="Poppins" pitchFamily="34" charset="-122"/>
+                <a:cs typeface="Poppins" pitchFamily="34" charset="-120"/>
+              </a:rPr>
+              <a:t>Jonas’ Feed</a:t>
+            </a:r>
+            <a:endParaRPr lang="en-US" sz="1600" dirty="0"/>
+          </a:p>
+        </p:txBody>
+      </p:sp>
+      <p:sp>
+        <p:nvSpPr>
+          <p:cNvPr id="30" name="Shape 27"/>
+          <p:cNvSpPr/>
+          <p:nvPr/>
+        </p:nvSpPr>
+        <p:spPr>
+          <a:xfrm>
+            <a:off x="9966960" y="914400"/>
+            <a:ext cx="1554480" cy="4297680"/>
+          </a:xfrm>
+          <a:prstGeom prst="roundRect">
+            <a:avLst>
+              <a:gd name="adj" fmla="val 17647"/>
+            </a:avLst>
+          </a:prstGeom>
+          <a:solidFill>
+            <a:srgbClr val="12301A"/>
+          </a:solidFill>
+          <a:ln w="12700">
+            <a:solidFill>
+              <a:srgbClr val="12301A"/>
+            </a:solidFill>
+            <a:prstDash val="solid"/>
+          </a:ln>
+        </p:spPr>
+      </p:sp>
+      <p:sp>
+        <p:nvSpPr>
+          <p:cNvPr id="31" name="Shape 28"/>
+          <p:cNvSpPr/>
+          <p:nvPr/>
+        </p:nvSpPr>
+        <p:spPr>
+          <a:xfrm>
+            <a:off x="10058400" y="1005840"/>
+            <a:ext cx="1371600" cy="4114800"/>
+          </a:xfrm>
+          <a:prstGeom prst="roundRect">
+            <a:avLst>
+              <a:gd name="adj" fmla="val 14667"/>
+            </a:avLst>
+          </a:prstGeom>
+          <a:solidFill>
+            <a:srgbClr val="FBFFF4"/>
+          </a:solidFill>
+          <a:ln w="12700">
+            <a:solidFill>
+              <a:srgbClr val="FBFFF4"/>
+            </a:solidFill>
+            <a:prstDash val="solid"/>
+          </a:ln>
+        </p:spPr>
+      </p:sp>
+      <p:sp>
+        <p:nvSpPr>
+          <p:cNvPr id="32" name="Shape 29"/>
+          <p:cNvSpPr/>
+          <p:nvPr/>
+        </p:nvSpPr>
+        <p:spPr>
+          <a:xfrm>
+            <a:off x="10149840" y="1188720"/>
+            <a:ext cx="1188720" cy="1097280"/>
+          </a:xfrm>
+          <a:prstGeom prst="roundRect">
+            <a:avLst>
+              <a:gd name="adj" fmla="val 10000"/>
+            </a:avLst>
+          </a:prstGeom>
+          <a:solidFill>
             <a:srgbClr val="B1FF37"/>
           </a:solidFill>
           <a:ln w="12700">
@@ -2645,14 +3377,53 @@
       </p:sp>
       <p:sp>
         <p:nvSpPr>
-          <p:cNvPr id="9" name="Text 6"/>
-          <p:cNvSpPr txBox="1"/>
-          <p:nvPr/>
-        </p:nvSpPr>
-        <p:spPr>
-          <a:xfrm>
-            <a:off x="8046720" y="1188720"/>
-            <a:ext cx="1828800" cy="4389120"/>
+          <p:cNvPr id="33" name="Text 30"/>
+          <p:cNvSpPr txBox="1"/>
+          <p:nvPr/>
+        </p:nvSpPr>
+        <p:spPr>
+          <a:xfrm>
+            <a:off x="10241280" y="1261872"/>
+            <a:ext cx="457200" cy="457200"/>
+          </a:xfrm>
+          <a:prstGeom prst="rect">
+            <a:avLst/>
+          </a:prstGeom>
+          <a:noFill/>
+          <a:ln/>
+        </p:spPr>
+        <p:txBody>
+          <a:bodyPr wrap="square" lIns="0" tIns="0" rIns="0" bIns="0" rtlCol="0" anchor="t"/>
+          <a:lstStyle/>
+          <a:p>
+            <a:pPr indent="0" marL="0">
+              <a:buNone/>
+            </a:pPr>
+            <a:r>
+              <a:rPr lang="en-US" sz="2200" b="1" dirty="0">
+                <a:solidFill>
+                  <a:srgbClr val="12301A"/>
+                </a:solidFill>
+                <a:latin typeface="Poppins" pitchFamily="34" charset="0"/>
+                <a:ea typeface="Poppins" pitchFamily="34" charset="-122"/>
+                <a:cs typeface="Poppins" pitchFamily="34" charset="-120"/>
+              </a:rPr>
+              <a:t>?</a:t>
+            </a:r>
+            <a:endParaRPr lang="en-US" sz="2200" dirty="0"/>
+          </a:p>
+        </p:txBody>
+      </p:sp>
+      <p:sp>
+        <p:nvSpPr>
+          <p:cNvPr id="34" name="Text 31"/>
+          <p:cNvSpPr txBox="1"/>
+          <p:nvPr/>
+        </p:nvSpPr>
+        <p:spPr>
+          <a:xfrm>
+            <a:off x="10241280" y="1755648"/>
+            <a:ext cx="1005840" cy="457200"/>
           </a:xfrm>
           <a:prstGeom prst="rect">
             <a:avLst/>
@@ -2664,351 +3435,270 @@
           <a:bodyPr wrap="square" lIns="0" tIns="0" rIns="0" bIns="0" rtlCol="0" anchor="ctr"/>
           <a:lstStyle/>
           <a:p>
+            <a:pPr indent="0" marL="0">
+              <a:buNone/>
+            </a:pPr>
+            <a:r>
+              <a:rPr lang="en-US" sz="1200" b="1" dirty="0">
+                <a:solidFill>
+                  <a:srgbClr val="0E1F0C"/>
+                </a:solidFill>
+                <a:latin typeface="Poppins" pitchFamily="34" charset="0"/>
+                <a:ea typeface="Poppins" pitchFamily="34" charset="-122"/>
+                <a:cs typeface="Poppins" pitchFamily="34" charset="-120"/>
+              </a:rPr>
+              <a:t>Katzen?</a:t>
+            </a:r>
+            <a:endParaRPr lang="en-US" sz="1200" dirty="0"/>
+          </a:p>
+        </p:txBody>
+      </p:sp>
+      <p:sp>
+        <p:nvSpPr>
+          <p:cNvPr id="35" name="Shape 32"/>
+          <p:cNvSpPr/>
+          <p:nvPr/>
+        </p:nvSpPr>
+        <p:spPr>
+          <a:xfrm>
+            <a:off x="10149840" y="2468880"/>
+            <a:ext cx="1188720" cy="1097280"/>
+          </a:xfrm>
+          <a:prstGeom prst="roundRect">
+            <a:avLst>
+              <a:gd name="adj" fmla="val 10000"/>
+            </a:avLst>
+          </a:prstGeom>
+          <a:solidFill>
+            <a:srgbClr val="B1FF37"/>
+          </a:solidFill>
+          <a:ln w="12700">
+            <a:solidFill>
+              <a:srgbClr val="B1FF37"/>
+            </a:solidFill>
+            <a:prstDash val="solid"/>
+          </a:ln>
+        </p:spPr>
+      </p:sp>
+      <p:sp>
+        <p:nvSpPr>
+          <p:cNvPr id="36" name="Text 33"/>
+          <p:cNvSpPr txBox="1"/>
+          <p:nvPr/>
+        </p:nvSpPr>
+        <p:spPr>
+          <a:xfrm>
+            <a:off x="10241280" y="2542032"/>
+            <a:ext cx="457200" cy="457200"/>
+          </a:xfrm>
+          <a:prstGeom prst="rect">
+            <a:avLst/>
+          </a:prstGeom>
+          <a:noFill/>
+          <a:ln/>
+        </p:spPr>
+        <p:txBody>
+          <a:bodyPr wrap="square" lIns="0" tIns="0" rIns="0" bIns="0" rtlCol="0" anchor="t"/>
+          <a:lstStyle/>
+          <a:p>
+            <a:pPr indent="0" marL="0">
+              <a:buNone/>
+            </a:pPr>
+            <a:r>
+              <a:rPr lang="en-US" sz="2200" b="1" dirty="0">
+                <a:solidFill>
+                  <a:srgbClr val="12301A"/>
+                </a:solidFill>
+                <a:latin typeface="Poppins" pitchFamily="34" charset="0"/>
+                <a:ea typeface="Poppins" pitchFamily="34" charset="-122"/>
+                <a:cs typeface="Poppins" pitchFamily="34" charset="-120"/>
+              </a:rPr>
+              <a:t>?</a:t>
+            </a:r>
+            <a:endParaRPr lang="en-US" sz="2200" dirty="0"/>
+          </a:p>
+        </p:txBody>
+      </p:sp>
+      <p:sp>
+        <p:nvSpPr>
+          <p:cNvPr id="37" name="Text 34"/>
+          <p:cNvSpPr txBox="1"/>
+          <p:nvPr/>
+        </p:nvSpPr>
+        <p:spPr>
+          <a:xfrm>
+            <a:off x="10241280" y="3035808"/>
+            <a:ext cx="1005840" cy="457200"/>
+          </a:xfrm>
+          <a:prstGeom prst="rect">
+            <a:avLst/>
+          </a:prstGeom>
+          <a:noFill/>
+          <a:ln/>
+        </p:spPr>
+        <p:txBody>
+          <a:bodyPr wrap="square" lIns="0" tIns="0" rIns="0" bIns="0" rtlCol="0" anchor="ctr"/>
+          <a:lstStyle/>
+          <a:p>
+            <a:pPr indent="0" marL="0">
+              <a:buNone/>
+            </a:pPr>
+            <a:r>
+              <a:rPr lang="en-US" sz="1200" b="1" dirty="0">
+                <a:solidFill>
+                  <a:srgbClr val="0E1F0C"/>
+                </a:solidFill>
+                <a:latin typeface="Poppins" pitchFamily="34" charset="0"/>
+                <a:ea typeface="Poppins" pitchFamily="34" charset="-122"/>
+                <a:cs typeface="Poppins" pitchFamily="34" charset="-120"/>
+              </a:rPr>
+              <a:t>Minecraft?</a:t>
+            </a:r>
+            <a:endParaRPr lang="en-US" sz="1200" dirty="0"/>
+          </a:p>
+        </p:txBody>
+      </p:sp>
+      <p:sp>
+        <p:nvSpPr>
+          <p:cNvPr id="38" name="Shape 35"/>
+          <p:cNvSpPr/>
+          <p:nvPr/>
+        </p:nvSpPr>
+        <p:spPr>
+          <a:xfrm>
+            <a:off x="10149840" y="3749040"/>
+            <a:ext cx="1188720" cy="1097280"/>
+          </a:xfrm>
+          <a:prstGeom prst="roundRect">
+            <a:avLst>
+              <a:gd name="adj" fmla="val 10000"/>
+            </a:avLst>
+          </a:prstGeom>
+          <a:solidFill>
+            <a:srgbClr val="B1FF37"/>
+          </a:solidFill>
+          <a:ln w="12700">
+            <a:solidFill>
+              <a:srgbClr val="B1FF37"/>
+            </a:solidFill>
+            <a:prstDash val="solid"/>
+          </a:ln>
+        </p:spPr>
+      </p:sp>
+      <p:sp>
+        <p:nvSpPr>
+          <p:cNvPr id="39" name="Text 36"/>
+          <p:cNvSpPr txBox="1"/>
+          <p:nvPr/>
+        </p:nvSpPr>
+        <p:spPr>
+          <a:xfrm>
+            <a:off x="10241280" y="3822192"/>
+            <a:ext cx="457200" cy="457200"/>
+          </a:xfrm>
+          <a:prstGeom prst="rect">
+            <a:avLst/>
+          </a:prstGeom>
+          <a:noFill/>
+          <a:ln/>
+        </p:spPr>
+        <p:txBody>
+          <a:bodyPr wrap="square" lIns="0" tIns="0" rIns="0" bIns="0" rtlCol="0" anchor="t"/>
+          <a:lstStyle/>
+          <a:p>
+            <a:pPr indent="0" marL="0">
+              <a:buNone/>
+            </a:pPr>
+            <a:r>
+              <a:rPr lang="en-US" sz="2200" b="1" dirty="0">
+                <a:solidFill>
+                  <a:srgbClr val="12301A"/>
+                </a:solidFill>
+                <a:latin typeface="Poppins" pitchFamily="34" charset="0"/>
+                <a:ea typeface="Poppins" pitchFamily="34" charset="-122"/>
+                <a:cs typeface="Poppins" pitchFamily="34" charset="-120"/>
+              </a:rPr>
+              <a:t>?</a:t>
+            </a:r>
+            <a:endParaRPr lang="en-US" sz="2200" dirty="0"/>
+          </a:p>
+        </p:txBody>
+      </p:sp>
+      <p:sp>
+        <p:nvSpPr>
+          <p:cNvPr id="40" name="Text 37"/>
+          <p:cNvSpPr txBox="1"/>
+          <p:nvPr/>
+        </p:nvSpPr>
+        <p:spPr>
+          <a:xfrm>
+            <a:off x="10241280" y="4315968"/>
+            <a:ext cx="1005840" cy="457200"/>
+          </a:xfrm>
+          <a:prstGeom prst="rect">
+            <a:avLst/>
+          </a:prstGeom>
+          <a:noFill/>
+          <a:ln/>
+        </p:spPr>
+        <p:txBody>
+          <a:bodyPr wrap="square" lIns="0" tIns="0" rIns="0" bIns="0" rtlCol="0" anchor="ctr"/>
+          <a:lstStyle/>
+          <a:p>
+            <a:pPr indent="0" marL="0">
+              <a:buNone/>
+            </a:pPr>
+            <a:r>
+              <a:rPr lang="en-US" sz="1200" b="1" dirty="0">
+                <a:solidFill>
+                  <a:srgbClr val="0E1F0C"/>
+                </a:solidFill>
+                <a:latin typeface="Poppins" pitchFamily="34" charset="0"/>
+                <a:ea typeface="Poppins" pitchFamily="34" charset="-122"/>
+                <a:cs typeface="Poppins" pitchFamily="34" charset="-120"/>
+              </a:rPr>
+              <a:t>Kochen?</a:t>
+            </a:r>
+            <a:endParaRPr lang="en-US" sz="1200" dirty="0"/>
+          </a:p>
+        </p:txBody>
+      </p:sp>
+      <p:sp>
+        <p:nvSpPr>
+          <p:cNvPr id="41" name="Text 38"/>
+          <p:cNvSpPr txBox="1"/>
+          <p:nvPr/>
+        </p:nvSpPr>
+        <p:spPr>
+          <a:xfrm>
+            <a:off x="9875520" y="5349240"/>
+            <a:ext cx="1737360" cy="365760"/>
+          </a:xfrm>
+          <a:prstGeom prst="rect">
+            <a:avLst/>
+          </a:prstGeom>
+          <a:noFill/>
+          <a:ln/>
+        </p:spPr>
+        <p:txBody>
+          <a:bodyPr wrap="square" lIns="0" tIns="0" rIns="0" bIns="0" rtlCol="0" anchor="t"/>
+          <a:lstStyle/>
+          <a:p>
             <a:pPr algn="ctr" indent="0" marL="0">
               <a:buNone/>
             </a:pPr>
             <a:r>
-              <a:rPr lang="en-US" sz="9600" b="1" dirty="0">
-                <a:solidFill>
-                  <a:srgbClr val="12301A"/>
-                </a:solidFill>
-                <a:latin typeface="Poppins" pitchFamily="34" charset="0"/>
-                <a:ea typeface="Poppins" pitchFamily="34" charset="-122"/>
-                <a:cs typeface="Poppins" pitchFamily="34" charset="-120"/>
-              </a:rPr>
-              <a:t>?</a:t>
-            </a:r>
-            <a:endParaRPr lang="en-US" sz="9600" dirty="0"/>
-          </a:p>
-        </p:txBody>
-      </p:sp>
-      <p:sp>
-        <p:nvSpPr>
-          <p:cNvPr id="10" name="Shape 7"/>
-          <p:cNvSpPr/>
-          <p:nvPr/>
-        </p:nvSpPr>
-        <p:spPr>
-          <a:xfrm>
-            <a:off x="6309360" y="1188720"/>
-            <a:ext cx="1737360" cy="640080"/>
-          </a:xfrm>
-          <a:prstGeom prst="wedgeRoundRectCallout">
-            <a:avLst>
-              <a:gd name="adj" fmla="val 28571"/>
-            </a:avLst>
-          </a:prstGeom>
-          <a:solidFill>
-            <a:srgbClr val="DDF3B8"/>
-          </a:solidFill>
-          <a:ln w="12700">
-            <a:solidFill>
-              <a:srgbClr val="DDF3B8"/>
-            </a:solidFill>
-            <a:prstDash val="solid"/>
-          </a:ln>
-        </p:spPr>
-      </p:sp>
-      <p:sp>
-        <p:nvSpPr>
-          <p:cNvPr id="11" name="Text 8"/>
-          <p:cNvSpPr txBox="1"/>
-          <p:nvPr/>
-        </p:nvSpPr>
-        <p:spPr>
-          <a:xfrm>
-            <a:off x="6309360" y="1188720"/>
-            <a:ext cx="1737360" cy="640080"/>
-          </a:xfrm>
-          <a:prstGeom prst="rect">
-            <a:avLst/>
-          </a:prstGeom>
-          <a:noFill/>
-          <a:ln/>
-        </p:spPr>
-        <p:txBody>
-          <a:bodyPr wrap="square" lIns="0" tIns="0" rIns="0" bIns="0" rtlCol="0" anchor="ctr"/>
-          <a:lstStyle/>
-          <a:p>
-            <a:pPr algn="ctr" indent="0" marL="0">
-              <a:buNone/>
-            </a:pPr>
-            <a:r>
-              <a:rPr lang="en-US" sz="1700" b="1" dirty="0">
-                <a:solidFill>
-                  <a:srgbClr val="0E1F0C"/>
-                </a:solidFill>
-                <a:latin typeface="Poppins" pitchFamily="34" charset="0"/>
-                <a:ea typeface="Poppins" pitchFamily="34" charset="-122"/>
-                <a:cs typeface="Poppins" pitchFamily="34" charset="-120"/>
-              </a:rPr>
-              <a:t>Tanzvideos</a:t>
-            </a:r>
-            <a:endParaRPr lang="en-US" sz="1700" dirty="0"/>
-          </a:p>
-        </p:txBody>
-      </p:sp>
-      <p:sp>
-        <p:nvSpPr>
-          <p:cNvPr id="12" name="Shape 9"/>
-          <p:cNvSpPr/>
-          <p:nvPr/>
-        </p:nvSpPr>
-        <p:spPr>
-          <a:xfrm>
-            <a:off x="10332720" y="2011680"/>
-            <a:ext cx="1280160" cy="640080"/>
-          </a:xfrm>
-          <a:prstGeom prst="wedgeRoundRectCallout">
-            <a:avLst>
-              <a:gd name="adj" fmla="val 28571"/>
-            </a:avLst>
-          </a:prstGeom>
-          <a:solidFill>
-            <a:srgbClr val="DDF3B8"/>
-          </a:solidFill>
-          <a:ln w="12700">
-            <a:solidFill>
-              <a:srgbClr val="DDF3B8"/>
-            </a:solidFill>
-            <a:prstDash val="solid"/>
-          </a:ln>
-        </p:spPr>
-      </p:sp>
-      <p:sp>
-        <p:nvSpPr>
-          <p:cNvPr id="13" name="Text 10"/>
-          <p:cNvSpPr txBox="1"/>
-          <p:nvPr/>
-        </p:nvSpPr>
-        <p:spPr>
-          <a:xfrm>
-            <a:off x="10332720" y="2011680"/>
-            <a:ext cx="1280160" cy="640080"/>
-          </a:xfrm>
-          <a:prstGeom prst="rect">
-            <a:avLst/>
-          </a:prstGeom>
-          <a:noFill/>
-          <a:ln/>
-        </p:spPr>
-        <p:txBody>
-          <a:bodyPr wrap="square" lIns="0" tIns="0" rIns="0" bIns="0" rtlCol="0" anchor="ctr"/>
-          <a:lstStyle/>
-          <a:p>
-            <a:pPr algn="ctr" indent="0" marL="0">
-              <a:buNone/>
-            </a:pPr>
-            <a:r>
-              <a:rPr lang="en-US" sz="1700" b="1" dirty="0">
-                <a:solidFill>
-                  <a:srgbClr val="0E1F0C"/>
-                </a:solidFill>
-                <a:latin typeface="Poppins" pitchFamily="34" charset="0"/>
-                <a:ea typeface="Poppins" pitchFamily="34" charset="-122"/>
-                <a:cs typeface="Poppins" pitchFamily="34" charset="-120"/>
-              </a:rPr>
-              <a:t>Fußball</a:t>
-            </a:r>
-            <a:endParaRPr lang="en-US" sz="1700" dirty="0"/>
-          </a:p>
-        </p:txBody>
-      </p:sp>
-      <p:sp>
-        <p:nvSpPr>
-          <p:cNvPr id="14" name="Shape 11"/>
-          <p:cNvSpPr/>
-          <p:nvPr/>
-        </p:nvSpPr>
-        <p:spPr>
-          <a:xfrm>
-            <a:off x="6126480" y="2743200"/>
-            <a:ext cx="1463040" cy="640080"/>
-          </a:xfrm>
-          <a:prstGeom prst="wedgeRoundRectCallout">
-            <a:avLst>
-              <a:gd name="adj" fmla="val 28571"/>
-            </a:avLst>
-          </a:prstGeom>
-          <a:solidFill>
-            <a:srgbClr val="B1FF37"/>
-          </a:solidFill>
-          <a:ln w="12700">
-            <a:solidFill>
-              <a:srgbClr val="B1FF37"/>
-            </a:solidFill>
-            <a:prstDash val="solid"/>
-          </a:ln>
-        </p:spPr>
-      </p:sp>
-      <p:sp>
-        <p:nvSpPr>
-          <p:cNvPr id="15" name="Text 12"/>
-          <p:cNvSpPr txBox="1"/>
-          <p:nvPr/>
-        </p:nvSpPr>
-        <p:spPr>
-          <a:xfrm>
-            <a:off x="6126480" y="2743200"/>
-            <a:ext cx="1463040" cy="640080"/>
-          </a:xfrm>
-          <a:prstGeom prst="rect">
-            <a:avLst/>
-          </a:prstGeom>
-          <a:noFill/>
-          <a:ln/>
-        </p:spPr>
-        <p:txBody>
-          <a:bodyPr wrap="square" lIns="0" tIns="0" rIns="0" bIns="0" rtlCol="0" anchor="ctr"/>
-          <a:lstStyle/>
-          <a:p>
-            <a:pPr algn="ctr" indent="0" marL="0">
-              <a:buNone/>
-            </a:pPr>
-            <a:r>
-              <a:rPr lang="en-US" sz="1700" b="1" dirty="0">
-                <a:solidFill>
-                  <a:srgbClr val="0E1F0C"/>
-                </a:solidFill>
-                <a:latin typeface="Poppins" pitchFamily="34" charset="0"/>
-                <a:ea typeface="Poppins" pitchFamily="34" charset="-122"/>
-                <a:cs typeface="Poppins" pitchFamily="34" charset="-120"/>
-              </a:rPr>
-              <a:t>Katzen?</a:t>
-            </a:r>
-            <a:endParaRPr lang="en-US" sz="1700" dirty="0"/>
-          </a:p>
-        </p:txBody>
-      </p:sp>
-      <p:sp>
-        <p:nvSpPr>
-          <p:cNvPr id="16" name="Shape 13"/>
-          <p:cNvSpPr/>
-          <p:nvPr/>
-        </p:nvSpPr>
-        <p:spPr>
-          <a:xfrm>
-            <a:off x="10241280" y="3291840"/>
-            <a:ext cx="1737360" cy="640080"/>
-          </a:xfrm>
-          <a:prstGeom prst="wedgeRoundRectCallout">
-            <a:avLst>
-              <a:gd name="adj" fmla="val 28571"/>
-            </a:avLst>
-          </a:prstGeom>
-          <a:solidFill>
-            <a:srgbClr val="B1FF37"/>
-          </a:solidFill>
-          <a:ln w="12700">
-            <a:solidFill>
-              <a:srgbClr val="B1FF37"/>
-            </a:solidFill>
-            <a:prstDash val="solid"/>
-          </a:ln>
-        </p:spPr>
-      </p:sp>
-      <p:sp>
-        <p:nvSpPr>
-          <p:cNvPr id="17" name="Text 14"/>
-          <p:cNvSpPr txBox="1"/>
-          <p:nvPr/>
-        </p:nvSpPr>
-        <p:spPr>
-          <a:xfrm>
-            <a:off x="10241280" y="3291840"/>
-            <a:ext cx="1737360" cy="640080"/>
-          </a:xfrm>
-          <a:prstGeom prst="rect">
-            <a:avLst/>
-          </a:prstGeom>
-          <a:noFill/>
-          <a:ln/>
-        </p:spPr>
-        <p:txBody>
-          <a:bodyPr wrap="square" lIns="0" tIns="0" rIns="0" bIns="0" rtlCol="0" anchor="ctr"/>
-          <a:lstStyle/>
-          <a:p>
-            <a:pPr algn="ctr" indent="0" marL="0">
-              <a:buNone/>
-            </a:pPr>
-            <a:r>
-              <a:rPr lang="en-US" sz="1700" b="1" dirty="0">
-                <a:solidFill>
-                  <a:srgbClr val="0E1F0C"/>
-                </a:solidFill>
-                <a:latin typeface="Poppins" pitchFamily="34" charset="0"/>
-                <a:ea typeface="Poppins" pitchFamily="34" charset="-122"/>
-                <a:cs typeface="Poppins" pitchFamily="34" charset="-120"/>
-              </a:rPr>
-              <a:t>Minecraft?</a:t>
-            </a:r>
-            <a:endParaRPr lang="en-US" sz="1700" dirty="0"/>
-          </a:p>
-        </p:txBody>
-      </p:sp>
-      <p:sp>
-        <p:nvSpPr>
-          <p:cNvPr id="18" name="Shape 15"/>
-          <p:cNvSpPr/>
-          <p:nvPr/>
-        </p:nvSpPr>
-        <p:spPr>
-          <a:xfrm>
-            <a:off x="6035040" y="4297680"/>
-            <a:ext cx="2011680" cy="640080"/>
-          </a:xfrm>
-          <a:prstGeom prst="wedgeRoundRectCallout">
-            <a:avLst>
-              <a:gd name="adj" fmla="val 28571"/>
-            </a:avLst>
-          </a:prstGeom>
-          <a:solidFill>
-            <a:srgbClr val="B1FF37"/>
-          </a:solidFill>
-          <a:ln w="12700">
-            <a:solidFill>
-              <a:srgbClr val="B1FF37"/>
-            </a:solidFill>
-            <a:prstDash val="solid"/>
-          </a:ln>
-        </p:spPr>
-      </p:sp>
-      <p:sp>
-        <p:nvSpPr>
-          <p:cNvPr id="19" name="Text 16"/>
-          <p:cNvSpPr txBox="1"/>
-          <p:nvPr/>
-        </p:nvSpPr>
-        <p:spPr>
-          <a:xfrm>
-            <a:off x="6035040" y="4297680"/>
-            <a:ext cx="2011680" cy="640080"/>
-          </a:xfrm>
-          <a:prstGeom prst="rect">
-            <a:avLst/>
-          </a:prstGeom>
-          <a:noFill/>
-          <a:ln/>
-        </p:spPr>
-        <p:txBody>
-          <a:bodyPr wrap="square" lIns="0" tIns="0" rIns="0" bIns="0" rtlCol="0" anchor="ctr"/>
-          <a:lstStyle/>
-          <a:p>
-            <a:pPr algn="ctr" indent="0" marL="0">
-              <a:buNone/>
-            </a:pPr>
-            <a:r>
-              <a:rPr lang="en-US" sz="1700" b="1" dirty="0">
-                <a:solidFill>
-                  <a:srgbClr val="0E1F0C"/>
-                </a:solidFill>
-                <a:latin typeface="Poppins" pitchFamily="34" charset="0"/>
-                <a:ea typeface="Poppins" pitchFamily="34" charset="-122"/>
-                <a:cs typeface="Poppins" pitchFamily="34" charset="-120"/>
-              </a:rPr>
-              <a:t>Kochrezepte?</a:t>
-            </a:r>
-            <a:endParaRPr lang="en-US" sz="1700" dirty="0"/>
+              <a:rPr lang="en-US" sz="1600" b="1" dirty="0">
+                <a:solidFill>
+                  <a:srgbClr val="26720A"/>
+                </a:solidFill>
+                <a:latin typeface="Poppins" pitchFamily="34" charset="0"/>
+                <a:ea typeface="Poppins" pitchFamily="34" charset="-122"/>
+                <a:cs typeface="Poppins" pitchFamily="34" charset="-120"/>
+              </a:rPr>
+              <a:t>Dein Feed</a:t>
+            </a:r>
+            <a:endParaRPr lang="en-US" sz="1600" dirty="0"/>
           </a:p>
         </p:txBody>
       </p:sp>

</xml_diff>

<commit_message>
Restore slide 1; add separate PPTX with the three feed graphics for animation
Co-Authored-By: Claude Sonnet 5.5 <noreply@anthropic.com>
Claude-Session: https://claude.ai/code/session_0139kriXJ67p3UvpR2gsSR9G
</commit_message>
<xml_diff>
--- a/videoslides/cleverbox-tiktok-slides.pptx
+++ b/videoslides/cleverbox-tiktok-slides.pptx
@@ -2570,12 +2570,12 @@
         </p:nvSpPr>
         <p:spPr>
           <a:xfrm>
-            <a:off x="6583680" y="914400"/>
-            <a:ext cx="1554480" cy="4297680"/>
+            <a:off x="7772400" y="731520"/>
+            <a:ext cx="2377440" cy="5303520"/>
           </a:xfrm>
           <a:prstGeom prst="roundRect">
             <a:avLst>
-              <a:gd name="adj" fmla="val 17647"/>
+              <a:gd name="adj" fmla="val 11538"/>
             </a:avLst>
           </a:prstGeom>
           <a:solidFill>
@@ -2597,12 +2597,12 @@
         </p:nvSpPr>
         <p:spPr>
           <a:xfrm>
-            <a:off x="6675120" y="1005840"/>
-            <a:ext cx="1371600" cy="4114800"/>
+            <a:off x="7863840" y="822960"/>
+            <a:ext cx="2194560" cy="5120640"/>
           </a:xfrm>
           <a:prstGeom prst="roundRect">
             <a:avLst>
-              <a:gd name="adj" fmla="val 14667"/>
+              <a:gd name="adj" fmla="val 9167"/>
             </a:avLst>
           </a:prstGeom>
           <a:solidFill>
@@ -2624,15 +2624,81 @@
         </p:nvSpPr>
         <p:spPr>
           <a:xfrm>
-            <a:off x="6766560" y="1188720"/>
-            <a:ext cx="1188720" cy="1097280"/>
+            <a:off x="8046720" y="1188720"/>
+            <a:ext cx="1828800" cy="4389120"/>
           </a:xfrm>
           <a:prstGeom prst="roundRect">
             <a:avLst>
-              <a:gd name="adj" fmla="val 10000"/>
+              <a:gd name="adj" fmla="val 6000"/>
             </a:avLst>
           </a:prstGeom>
           <a:solidFill>
+            <a:srgbClr val="B1FF37"/>
+          </a:solidFill>
+          <a:ln w="12700">
+            <a:solidFill>
+              <a:srgbClr val="B1FF37"/>
+            </a:solidFill>
+            <a:prstDash val="solid"/>
+          </a:ln>
+        </p:spPr>
+      </p:sp>
+      <p:sp>
+        <p:nvSpPr>
+          <p:cNvPr id="9" name="Text 6"/>
+          <p:cNvSpPr txBox="1"/>
+          <p:nvPr/>
+        </p:nvSpPr>
+        <p:spPr>
+          <a:xfrm>
+            <a:off x="8046720" y="1188720"/>
+            <a:ext cx="1828800" cy="4389120"/>
+          </a:xfrm>
+          <a:prstGeom prst="rect">
+            <a:avLst/>
+          </a:prstGeom>
+          <a:noFill/>
+          <a:ln/>
+        </p:spPr>
+        <p:txBody>
+          <a:bodyPr wrap="square" lIns="0" tIns="0" rIns="0" bIns="0" rtlCol="0" anchor="ctr"/>
+          <a:lstStyle/>
+          <a:p>
+            <a:pPr algn="ctr" indent="0" marL="0">
+              <a:buNone/>
+            </a:pPr>
+            <a:r>
+              <a:rPr lang="en-US" sz="9600" b="1" dirty="0">
+                <a:solidFill>
+                  <a:srgbClr val="12301A"/>
+                </a:solidFill>
+                <a:latin typeface="Poppins" pitchFamily="34" charset="0"/>
+                <a:ea typeface="Poppins" pitchFamily="34" charset="-122"/>
+                <a:cs typeface="Poppins" pitchFamily="34" charset="-120"/>
+              </a:rPr>
+              <a:t>?</a:t>
+            </a:r>
+            <a:endParaRPr lang="en-US" sz="9600" dirty="0"/>
+          </a:p>
+        </p:txBody>
+      </p:sp>
+      <p:sp>
+        <p:nvSpPr>
+          <p:cNvPr id="10" name="Shape 7"/>
+          <p:cNvSpPr/>
+          <p:nvPr/>
+        </p:nvSpPr>
+        <p:spPr>
+          <a:xfrm>
+            <a:off x="6309360" y="1188720"/>
+            <a:ext cx="1737360" cy="640080"/>
+          </a:xfrm>
+          <a:prstGeom prst="wedgeRoundRectCallout">
+            <a:avLst>
+              <a:gd name="adj" fmla="val 28571"/>
+            </a:avLst>
+          </a:prstGeom>
+          <a:solidFill>
             <a:srgbClr val="DDF3B8"/>
           </a:solidFill>
           <a:ln w="12700">
@@ -2645,39 +2711,80 @@
       </p:sp>
       <p:sp>
         <p:nvSpPr>
-          <p:cNvPr id="9" name="Shape 6"/>
-          <p:cNvSpPr/>
-          <p:nvPr/>
-        </p:nvSpPr>
-        <p:spPr>
-          <a:xfrm>
-            <a:off x="6903720" y="1353312"/>
-            <a:ext cx="365760" cy="329184"/>
-          </a:xfrm>
-          <a:prstGeom prst="heart">
-            <a:avLst/>
-          </a:prstGeom>
-          <a:solidFill>
-            <a:srgbClr val="26720A"/>
+          <p:cNvPr id="11" name="Text 8"/>
+          <p:cNvSpPr txBox="1"/>
+          <p:nvPr/>
+        </p:nvSpPr>
+        <p:spPr>
+          <a:xfrm>
+            <a:off x="6309360" y="1188720"/>
+            <a:ext cx="1737360" cy="640080"/>
+          </a:xfrm>
+          <a:prstGeom prst="rect">
+            <a:avLst/>
+          </a:prstGeom>
+          <a:noFill/>
+          <a:ln/>
+        </p:spPr>
+        <p:txBody>
+          <a:bodyPr wrap="square" lIns="0" tIns="0" rIns="0" bIns="0" rtlCol="0" anchor="ctr"/>
+          <a:lstStyle/>
+          <a:p>
+            <a:pPr algn="ctr" indent="0" marL="0">
+              <a:buNone/>
+            </a:pPr>
+            <a:r>
+              <a:rPr lang="en-US" sz="1700" b="1" dirty="0">
+                <a:solidFill>
+                  <a:srgbClr val="0E1F0C"/>
+                </a:solidFill>
+                <a:latin typeface="Poppins" pitchFamily="34" charset="0"/>
+                <a:ea typeface="Poppins" pitchFamily="34" charset="-122"/>
+                <a:cs typeface="Poppins" pitchFamily="34" charset="-120"/>
+              </a:rPr>
+              <a:t>Tanzvideos</a:t>
+            </a:r>
+            <a:endParaRPr lang="en-US" sz="1700" dirty="0"/>
+          </a:p>
+        </p:txBody>
+      </p:sp>
+      <p:sp>
+        <p:nvSpPr>
+          <p:cNvPr id="12" name="Shape 9"/>
+          <p:cNvSpPr/>
+          <p:nvPr/>
+        </p:nvSpPr>
+        <p:spPr>
+          <a:xfrm>
+            <a:off x="10332720" y="2011680"/>
+            <a:ext cx="1280160" cy="640080"/>
+          </a:xfrm>
+          <a:prstGeom prst="wedgeRoundRectCallout">
+            <a:avLst>
+              <a:gd name="adj" fmla="val 28571"/>
+            </a:avLst>
+          </a:prstGeom>
+          <a:solidFill>
+            <a:srgbClr val="DDF3B8"/>
           </a:solidFill>
           <a:ln w="12700">
             <a:solidFill>
-              <a:srgbClr val="26720A"/>
-            </a:solidFill>
-            <a:prstDash val="solid"/>
-          </a:ln>
-        </p:spPr>
-      </p:sp>
-      <p:sp>
-        <p:nvSpPr>
-          <p:cNvPr id="10" name="Text 7"/>
-          <p:cNvSpPr txBox="1"/>
-          <p:nvPr/>
-        </p:nvSpPr>
-        <p:spPr>
-          <a:xfrm>
-            <a:off x="6858000" y="1755648"/>
-            <a:ext cx="1005840" cy="457200"/>
+              <a:srgbClr val="DDF3B8"/>
+            </a:solidFill>
+            <a:prstDash val="solid"/>
+          </a:ln>
+        </p:spPr>
+      </p:sp>
+      <p:sp>
+        <p:nvSpPr>
+          <p:cNvPr id="13" name="Text 10"/>
+          <p:cNvSpPr txBox="1"/>
+          <p:nvPr/>
+        </p:nvSpPr>
+        <p:spPr>
+          <a:xfrm>
+            <a:off x="10332720" y="2011680"/>
+            <a:ext cx="1280160" cy="640080"/>
           </a:xfrm>
           <a:prstGeom prst="rect">
             <a:avLst/>
@@ -2689,11 +2796,11 @@
           <a:bodyPr wrap="square" lIns="0" tIns="0" rIns="0" bIns="0" rtlCol="0" anchor="ctr"/>
           <a:lstStyle/>
           <a:p>
-            <a:pPr indent="0" marL="0">
-              <a:buNone/>
-            </a:pPr>
-            <a:r>
-              <a:rPr lang="en-US" sz="1200" b="1" dirty="0">
+            <a:pPr algn="ctr" indent="0" marL="0">
+              <a:buNone/>
+            </a:pPr>
+            <a:r>
+              <a:rPr lang="en-US" sz="1700" b="1" dirty="0">
                 <a:solidFill>
                   <a:srgbClr val="0E1F0C"/>
                 </a:solidFill>
@@ -2701,74 +2808,115 @@
                 <a:ea typeface="Poppins" pitchFamily="34" charset="-122"/>
                 <a:cs typeface="Poppins" pitchFamily="34" charset="-120"/>
               </a:rPr>
-              <a:t>Tanz-Challenge</a:t>
-            </a:r>
-            <a:endParaRPr lang="en-US" sz="1200" dirty="0"/>
-          </a:p>
-        </p:txBody>
-      </p:sp>
-      <p:sp>
-        <p:nvSpPr>
-          <p:cNvPr id="11" name="Shape 8"/>
-          <p:cNvSpPr/>
-          <p:nvPr/>
-        </p:nvSpPr>
-        <p:spPr>
-          <a:xfrm>
-            <a:off x="6766560" y="2468880"/>
-            <a:ext cx="1188720" cy="1097280"/>
-          </a:xfrm>
-          <a:prstGeom prst="roundRect">
+              <a:t>Fußball</a:t>
+            </a:r>
+            <a:endParaRPr lang="en-US" sz="1700" dirty="0"/>
+          </a:p>
+        </p:txBody>
+      </p:sp>
+      <p:sp>
+        <p:nvSpPr>
+          <p:cNvPr id="14" name="Shape 11"/>
+          <p:cNvSpPr/>
+          <p:nvPr/>
+        </p:nvSpPr>
+        <p:spPr>
+          <a:xfrm>
+            <a:off x="6126480" y="2743200"/>
+            <a:ext cx="1463040" cy="640080"/>
+          </a:xfrm>
+          <a:prstGeom prst="wedgeRoundRectCallout">
             <a:avLst>
-              <a:gd name="adj" fmla="val 10000"/>
+              <a:gd name="adj" fmla="val 28571"/>
             </a:avLst>
           </a:prstGeom>
           <a:solidFill>
-            <a:srgbClr val="DDF3B8"/>
+            <a:srgbClr val="B1FF37"/>
           </a:solidFill>
           <a:ln w="12700">
             <a:solidFill>
-              <a:srgbClr val="DDF3B8"/>
-            </a:solidFill>
-            <a:prstDash val="solid"/>
-          </a:ln>
-        </p:spPr>
-      </p:sp>
-      <p:sp>
-        <p:nvSpPr>
-          <p:cNvPr id="12" name="Shape 9"/>
-          <p:cNvSpPr/>
-          <p:nvPr/>
-        </p:nvSpPr>
-        <p:spPr>
-          <a:xfrm>
-            <a:off x="6903720" y="2633472"/>
-            <a:ext cx="365760" cy="329184"/>
-          </a:xfrm>
-          <a:prstGeom prst="heart">
-            <a:avLst/>
-          </a:prstGeom>
-          <a:solidFill>
-            <a:srgbClr val="26720A"/>
+              <a:srgbClr val="B1FF37"/>
+            </a:solidFill>
+            <a:prstDash val="solid"/>
+          </a:ln>
+        </p:spPr>
+      </p:sp>
+      <p:sp>
+        <p:nvSpPr>
+          <p:cNvPr id="15" name="Text 12"/>
+          <p:cNvSpPr txBox="1"/>
+          <p:nvPr/>
+        </p:nvSpPr>
+        <p:spPr>
+          <a:xfrm>
+            <a:off x="6126480" y="2743200"/>
+            <a:ext cx="1463040" cy="640080"/>
+          </a:xfrm>
+          <a:prstGeom prst="rect">
+            <a:avLst/>
+          </a:prstGeom>
+          <a:noFill/>
+          <a:ln/>
+        </p:spPr>
+        <p:txBody>
+          <a:bodyPr wrap="square" lIns="0" tIns="0" rIns="0" bIns="0" rtlCol="0" anchor="ctr"/>
+          <a:lstStyle/>
+          <a:p>
+            <a:pPr algn="ctr" indent="0" marL="0">
+              <a:buNone/>
+            </a:pPr>
+            <a:r>
+              <a:rPr lang="en-US" sz="1700" b="1" dirty="0">
+                <a:solidFill>
+                  <a:srgbClr val="0E1F0C"/>
+                </a:solidFill>
+                <a:latin typeface="Poppins" pitchFamily="34" charset="0"/>
+                <a:ea typeface="Poppins" pitchFamily="34" charset="-122"/>
+                <a:cs typeface="Poppins" pitchFamily="34" charset="-120"/>
+              </a:rPr>
+              <a:t>Katzen?</a:t>
+            </a:r>
+            <a:endParaRPr lang="en-US" sz="1700" dirty="0"/>
+          </a:p>
+        </p:txBody>
+      </p:sp>
+      <p:sp>
+        <p:nvSpPr>
+          <p:cNvPr id="16" name="Shape 13"/>
+          <p:cNvSpPr/>
+          <p:nvPr/>
+        </p:nvSpPr>
+        <p:spPr>
+          <a:xfrm>
+            <a:off x="10241280" y="3291840"/>
+            <a:ext cx="1737360" cy="640080"/>
+          </a:xfrm>
+          <a:prstGeom prst="wedgeRoundRectCallout">
+            <a:avLst>
+              <a:gd name="adj" fmla="val 28571"/>
+            </a:avLst>
+          </a:prstGeom>
+          <a:solidFill>
+            <a:srgbClr val="B1FF37"/>
           </a:solidFill>
           <a:ln w="12700">
             <a:solidFill>
-              <a:srgbClr val="26720A"/>
-            </a:solidFill>
-            <a:prstDash val="solid"/>
-          </a:ln>
-        </p:spPr>
-      </p:sp>
-      <p:sp>
-        <p:nvSpPr>
-          <p:cNvPr id="13" name="Text 10"/>
-          <p:cNvSpPr txBox="1"/>
-          <p:nvPr/>
-        </p:nvSpPr>
-        <p:spPr>
-          <a:xfrm>
-            <a:off x="6858000" y="3035808"/>
-            <a:ext cx="1005840" cy="457200"/>
+              <a:srgbClr val="B1FF37"/>
+            </a:solidFill>
+            <a:prstDash val="solid"/>
+          </a:ln>
+        </p:spPr>
+      </p:sp>
+      <p:sp>
+        <p:nvSpPr>
+          <p:cNvPr id="17" name="Text 14"/>
+          <p:cNvSpPr txBox="1"/>
+          <p:nvPr/>
+        </p:nvSpPr>
+        <p:spPr>
+          <a:xfrm>
+            <a:off x="10241280" y="3291840"/>
+            <a:ext cx="1737360" cy="640080"/>
           </a:xfrm>
           <a:prstGeom prst="rect">
             <a:avLst/>
@@ -2780,11 +2928,11 @@
           <a:bodyPr wrap="square" lIns="0" tIns="0" rIns="0" bIns="0" rtlCol="0" anchor="ctr"/>
           <a:lstStyle/>
           <a:p>
-            <a:pPr indent="0" marL="0">
-              <a:buNone/>
-            </a:pPr>
-            <a:r>
-              <a:rPr lang="en-US" sz="1200" b="1" dirty="0">
+            <a:pPr algn="ctr" indent="0" marL="0">
+              <a:buNone/>
+            </a:pPr>
+            <a:r>
+              <a:rPr lang="en-US" sz="1700" b="1" dirty="0">
                 <a:solidFill>
                   <a:srgbClr val="0E1F0C"/>
                 </a:solidFill>
@@ -2792,74 +2940,49 @@
                 <a:ea typeface="Poppins" pitchFamily="34" charset="-122"/>
                 <a:cs typeface="Poppins" pitchFamily="34" charset="-120"/>
               </a:rPr>
-              <a:t>Choreo lernen</a:t>
-            </a:r>
-            <a:endParaRPr lang="en-US" sz="1200" dirty="0"/>
-          </a:p>
-        </p:txBody>
-      </p:sp>
-      <p:sp>
-        <p:nvSpPr>
-          <p:cNvPr id="14" name="Shape 11"/>
-          <p:cNvSpPr/>
-          <p:nvPr/>
-        </p:nvSpPr>
-        <p:spPr>
-          <a:xfrm>
-            <a:off x="6766560" y="3749040"/>
-            <a:ext cx="1188720" cy="1097280"/>
-          </a:xfrm>
-          <a:prstGeom prst="roundRect">
+              <a:t>Minecraft?</a:t>
+            </a:r>
+            <a:endParaRPr lang="en-US" sz="1700" dirty="0"/>
+          </a:p>
+        </p:txBody>
+      </p:sp>
+      <p:sp>
+        <p:nvSpPr>
+          <p:cNvPr id="18" name="Shape 15"/>
+          <p:cNvSpPr/>
+          <p:nvPr/>
+        </p:nvSpPr>
+        <p:spPr>
+          <a:xfrm>
+            <a:off x="6035040" y="4297680"/>
+            <a:ext cx="2011680" cy="640080"/>
+          </a:xfrm>
+          <a:prstGeom prst="wedgeRoundRectCallout">
             <a:avLst>
-              <a:gd name="adj" fmla="val 10000"/>
+              <a:gd name="adj" fmla="val 28571"/>
             </a:avLst>
           </a:prstGeom>
           <a:solidFill>
-            <a:srgbClr val="DDF3B8"/>
+            <a:srgbClr val="B1FF37"/>
           </a:solidFill>
           <a:ln w="12700">
             <a:solidFill>
-              <a:srgbClr val="DDF3B8"/>
-            </a:solidFill>
-            <a:prstDash val="solid"/>
-          </a:ln>
-        </p:spPr>
-      </p:sp>
-      <p:sp>
-        <p:nvSpPr>
-          <p:cNvPr id="15" name="Shape 12"/>
-          <p:cNvSpPr/>
-          <p:nvPr/>
-        </p:nvSpPr>
-        <p:spPr>
-          <a:xfrm>
-            <a:off x="6903720" y="3913632"/>
-            <a:ext cx="365760" cy="329184"/>
-          </a:xfrm>
-          <a:prstGeom prst="heart">
-            <a:avLst/>
-          </a:prstGeom>
-          <a:solidFill>
-            <a:srgbClr val="26720A"/>
-          </a:solidFill>
-          <a:ln w="12700">
-            <a:solidFill>
-              <a:srgbClr val="26720A"/>
-            </a:solidFill>
-            <a:prstDash val="solid"/>
-          </a:ln>
-        </p:spPr>
-      </p:sp>
-      <p:sp>
-        <p:nvSpPr>
-          <p:cNvPr id="16" name="Text 13"/>
-          <p:cNvSpPr txBox="1"/>
-          <p:nvPr/>
-        </p:nvSpPr>
-        <p:spPr>
-          <a:xfrm>
-            <a:off x="6858000" y="4315968"/>
-            <a:ext cx="1005840" cy="457200"/>
+              <a:srgbClr val="B1FF37"/>
+            </a:solidFill>
+            <a:prstDash val="solid"/>
+          </a:ln>
+        </p:spPr>
+      </p:sp>
+      <p:sp>
+        <p:nvSpPr>
+          <p:cNvPr id="19" name="Text 16"/>
+          <p:cNvSpPr txBox="1"/>
+          <p:nvPr/>
+        </p:nvSpPr>
+        <p:spPr>
+          <a:xfrm>
+            <a:off x="6035040" y="4297680"/>
+            <a:ext cx="2011680" cy="640080"/>
           </a:xfrm>
           <a:prstGeom prst="rect">
             <a:avLst/>
@@ -2871,11 +2994,11 @@
           <a:bodyPr wrap="square" lIns="0" tIns="0" rIns="0" bIns="0" rtlCol="0" anchor="ctr"/>
           <a:lstStyle/>
           <a:p>
-            <a:pPr indent="0" marL="0">
-              <a:buNone/>
-            </a:pPr>
-            <a:r>
-              <a:rPr lang="en-US" sz="1200" b="1" dirty="0">
+            <a:pPr algn="ctr" indent="0" marL="0">
+              <a:buNone/>
+            </a:pPr>
+            <a:r>
+              <a:rPr lang="en-US" sz="1700" b="1" dirty="0">
                 <a:solidFill>
                   <a:srgbClr val="0E1F0C"/>
                 </a:solidFill>
@@ -2883,822 +3006,9 @@
                 <a:ea typeface="Poppins" pitchFamily="34" charset="-122"/>
                 <a:cs typeface="Poppins" pitchFamily="34" charset="-120"/>
               </a:rPr>
-              <a:t>Duett-Tanz</a:t>
-            </a:r>
-            <a:endParaRPr lang="en-US" sz="1200" dirty="0"/>
-          </a:p>
-        </p:txBody>
-      </p:sp>
-      <p:sp>
-        <p:nvSpPr>
-          <p:cNvPr id="17" name="Text 14"/>
-          <p:cNvSpPr txBox="1"/>
-          <p:nvPr/>
-        </p:nvSpPr>
-        <p:spPr>
-          <a:xfrm>
-            <a:off x="6492240" y="5349240"/>
-            <a:ext cx="1737360" cy="365760"/>
-          </a:xfrm>
-          <a:prstGeom prst="rect">
-            <a:avLst/>
-          </a:prstGeom>
-          <a:noFill/>
-          <a:ln/>
-        </p:spPr>
-        <p:txBody>
-          <a:bodyPr wrap="square" lIns="0" tIns="0" rIns="0" bIns="0" rtlCol="0" anchor="t"/>
-          <a:lstStyle/>
-          <a:p>
-            <a:pPr algn="ctr" indent="0" marL="0">
-              <a:buNone/>
-            </a:pPr>
-            <a:r>
-              <a:rPr lang="en-US" sz="1600" b="1" dirty="0">
-                <a:solidFill>
-                  <a:srgbClr val="0E1F0C"/>
-                </a:solidFill>
-                <a:latin typeface="Poppins" pitchFamily="34" charset="0"/>
-                <a:ea typeface="Poppins" pitchFamily="34" charset="-122"/>
-                <a:cs typeface="Poppins" pitchFamily="34" charset="-120"/>
-              </a:rPr>
-              <a:t>Lenas Feed</a:t>
-            </a:r>
-            <a:endParaRPr lang="en-US" sz="1600" dirty="0"/>
-          </a:p>
-        </p:txBody>
-      </p:sp>
-      <p:sp>
-        <p:nvSpPr>
-          <p:cNvPr id="18" name="Shape 15"/>
-          <p:cNvSpPr/>
-          <p:nvPr/>
-        </p:nvSpPr>
-        <p:spPr>
-          <a:xfrm>
-            <a:off x="8275320" y="914400"/>
-            <a:ext cx="1554480" cy="4297680"/>
-          </a:xfrm>
-          <a:prstGeom prst="roundRect">
-            <a:avLst>
-              <a:gd name="adj" fmla="val 17647"/>
-            </a:avLst>
-          </a:prstGeom>
-          <a:solidFill>
-            <a:srgbClr val="12301A"/>
-          </a:solidFill>
-          <a:ln w="12700">
-            <a:solidFill>
-              <a:srgbClr val="12301A"/>
-            </a:solidFill>
-            <a:prstDash val="solid"/>
-          </a:ln>
-        </p:spPr>
-      </p:sp>
-      <p:sp>
-        <p:nvSpPr>
-          <p:cNvPr id="19" name="Shape 16"/>
-          <p:cNvSpPr/>
-          <p:nvPr/>
-        </p:nvSpPr>
-        <p:spPr>
-          <a:xfrm>
-            <a:off x="8366760" y="1005840"/>
-            <a:ext cx="1371600" cy="4114800"/>
-          </a:xfrm>
-          <a:prstGeom prst="roundRect">
-            <a:avLst>
-              <a:gd name="adj" fmla="val 14667"/>
-            </a:avLst>
-          </a:prstGeom>
-          <a:solidFill>
-            <a:srgbClr val="FBFFF4"/>
-          </a:solidFill>
-          <a:ln w="12700">
-            <a:solidFill>
-              <a:srgbClr val="FBFFF4"/>
-            </a:solidFill>
-            <a:prstDash val="solid"/>
-          </a:ln>
-        </p:spPr>
-      </p:sp>
-      <p:sp>
-        <p:nvSpPr>
-          <p:cNvPr id="20" name="Shape 17"/>
-          <p:cNvSpPr/>
-          <p:nvPr/>
-        </p:nvSpPr>
-        <p:spPr>
-          <a:xfrm>
-            <a:off x="8458200" y="1188720"/>
-            <a:ext cx="1188720" cy="1097280"/>
-          </a:xfrm>
-          <a:prstGeom prst="roundRect">
-            <a:avLst>
-              <a:gd name="adj" fmla="val 10000"/>
-            </a:avLst>
-          </a:prstGeom>
-          <a:solidFill>
-            <a:srgbClr val="DDF3B8"/>
-          </a:solidFill>
-          <a:ln w="12700">
-            <a:solidFill>
-              <a:srgbClr val="DDF3B8"/>
-            </a:solidFill>
-            <a:prstDash val="solid"/>
-          </a:ln>
-        </p:spPr>
-      </p:sp>
-      <p:sp>
-        <p:nvSpPr>
-          <p:cNvPr id="21" name="Shape 18"/>
-          <p:cNvSpPr/>
-          <p:nvPr/>
-        </p:nvSpPr>
-        <p:spPr>
-          <a:xfrm>
-            <a:off x="8595360" y="1335024"/>
-            <a:ext cx="365760" cy="365760"/>
-          </a:xfrm>
-          <a:prstGeom prst="ellipse">
-            <a:avLst/>
-          </a:prstGeom>
-          <a:solidFill>
-            <a:srgbClr val="26720A"/>
-          </a:solidFill>
-          <a:ln w="12700">
-            <a:solidFill>
-              <a:srgbClr val="26720A"/>
-            </a:solidFill>
-            <a:prstDash val="solid"/>
-          </a:ln>
-        </p:spPr>
-      </p:sp>
-      <p:sp>
-        <p:nvSpPr>
-          <p:cNvPr id="22" name="Text 19"/>
-          <p:cNvSpPr txBox="1"/>
-          <p:nvPr/>
-        </p:nvSpPr>
-        <p:spPr>
-          <a:xfrm>
-            <a:off x="8549640" y="1755648"/>
-            <a:ext cx="1005840" cy="457200"/>
-          </a:xfrm>
-          <a:prstGeom prst="rect">
-            <a:avLst/>
-          </a:prstGeom>
-          <a:noFill/>
-          <a:ln/>
-        </p:spPr>
-        <p:txBody>
-          <a:bodyPr wrap="square" lIns="0" tIns="0" rIns="0" bIns="0" rtlCol="0" anchor="ctr"/>
-          <a:lstStyle/>
-          <a:p>
-            <a:pPr indent="0" marL="0">
-              <a:buNone/>
-            </a:pPr>
-            <a:r>
-              <a:rPr lang="en-US" sz="1200" b="1" dirty="0">
-                <a:solidFill>
-                  <a:srgbClr val="0E1F0C"/>
-                </a:solidFill>
-                <a:latin typeface="Poppins" pitchFamily="34" charset="0"/>
-                <a:ea typeface="Poppins" pitchFamily="34" charset="-122"/>
-                <a:cs typeface="Poppins" pitchFamily="34" charset="-120"/>
-              </a:rPr>
-              <a:t>Elfmeter-Tricks</a:t>
-            </a:r>
-            <a:endParaRPr lang="en-US" sz="1200" dirty="0"/>
-          </a:p>
-        </p:txBody>
-      </p:sp>
-      <p:sp>
-        <p:nvSpPr>
-          <p:cNvPr id="23" name="Shape 20"/>
-          <p:cNvSpPr/>
-          <p:nvPr/>
-        </p:nvSpPr>
-        <p:spPr>
-          <a:xfrm>
-            <a:off x="8458200" y="2468880"/>
-            <a:ext cx="1188720" cy="1097280"/>
-          </a:xfrm>
-          <a:prstGeom prst="roundRect">
-            <a:avLst>
-              <a:gd name="adj" fmla="val 10000"/>
-            </a:avLst>
-          </a:prstGeom>
-          <a:solidFill>
-            <a:srgbClr val="DDF3B8"/>
-          </a:solidFill>
-          <a:ln w="12700">
-            <a:solidFill>
-              <a:srgbClr val="DDF3B8"/>
-            </a:solidFill>
-            <a:prstDash val="solid"/>
-          </a:ln>
-        </p:spPr>
-      </p:sp>
-      <p:sp>
-        <p:nvSpPr>
-          <p:cNvPr id="24" name="Shape 21"/>
-          <p:cNvSpPr/>
-          <p:nvPr/>
-        </p:nvSpPr>
-        <p:spPr>
-          <a:xfrm>
-            <a:off x="8595360" y="2615184"/>
-            <a:ext cx="365760" cy="365760"/>
-          </a:xfrm>
-          <a:prstGeom prst="ellipse">
-            <a:avLst/>
-          </a:prstGeom>
-          <a:solidFill>
-            <a:srgbClr val="26720A"/>
-          </a:solidFill>
-          <a:ln w="12700">
-            <a:solidFill>
-              <a:srgbClr val="26720A"/>
-            </a:solidFill>
-            <a:prstDash val="solid"/>
-          </a:ln>
-        </p:spPr>
-      </p:sp>
-      <p:sp>
-        <p:nvSpPr>
-          <p:cNvPr id="25" name="Text 22"/>
-          <p:cNvSpPr txBox="1"/>
-          <p:nvPr/>
-        </p:nvSpPr>
-        <p:spPr>
-          <a:xfrm>
-            <a:off x="8549640" y="3035808"/>
-            <a:ext cx="1005840" cy="457200"/>
-          </a:xfrm>
-          <a:prstGeom prst="rect">
-            <a:avLst/>
-          </a:prstGeom>
-          <a:noFill/>
-          <a:ln/>
-        </p:spPr>
-        <p:txBody>
-          <a:bodyPr wrap="square" lIns="0" tIns="0" rIns="0" bIns="0" rtlCol="0" anchor="ctr"/>
-          <a:lstStyle/>
-          <a:p>
-            <a:pPr indent="0" marL="0">
-              <a:buNone/>
-            </a:pPr>
-            <a:r>
-              <a:rPr lang="en-US" sz="1200" b="1" dirty="0">
-                <a:solidFill>
-                  <a:srgbClr val="0E1F0C"/>
-                </a:solidFill>
-                <a:latin typeface="Poppins" pitchFamily="34" charset="0"/>
-                <a:ea typeface="Poppins" pitchFamily="34" charset="-122"/>
-                <a:cs typeface="Poppins" pitchFamily="34" charset="-120"/>
-              </a:rPr>
-              <a:t>Tor des Monats</a:t>
-            </a:r>
-            <a:endParaRPr lang="en-US" sz="1200" dirty="0"/>
-          </a:p>
-        </p:txBody>
-      </p:sp>
-      <p:sp>
-        <p:nvSpPr>
-          <p:cNvPr id="26" name="Shape 23"/>
-          <p:cNvSpPr/>
-          <p:nvPr/>
-        </p:nvSpPr>
-        <p:spPr>
-          <a:xfrm>
-            <a:off x="8458200" y="3749040"/>
-            <a:ext cx="1188720" cy="1097280"/>
-          </a:xfrm>
-          <a:prstGeom prst="roundRect">
-            <a:avLst>
-              <a:gd name="adj" fmla="val 10000"/>
-            </a:avLst>
-          </a:prstGeom>
-          <a:solidFill>
-            <a:srgbClr val="DDF3B8"/>
-          </a:solidFill>
-          <a:ln w="12700">
-            <a:solidFill>
-              <a:srgbClr val="DDF3B8"/>
-            </a:solidFill>
-            <a:prstDash val="solid"/>
-          </a:ln>
-        </p:spPr>
-      </p:sp>
-      <p:sp>
-        <p:nvSpPr>
-          <p:cNvPr id="27" name="Shape 24"/>
-          <p:cNvSpPr/>
-          <p:nvPr/>
-        </p:nvSpPr>
-        <p:spPr>
-          <a:xfrm>
-            <a:off x="8595360" y="3895344"/>
-            <a:ext cx="365760" cy="365760"/>
-          </a:xfrm>
-          <a:prstGeom prst="ellipse">
-            <a:avLst/>
-          </a:prstGeom>
-          <a:solidFill>
-            <a:srgbClr val="26720A"/>
-          </a:solidFill>
-          <a:ln w="12700">
-            <a:solidFill>
-              <a:srgbClr val="26720A"/>
-            </a:solidFill>
-            <a:prstDash val="solid"/>
-          </a:ln>
-        </p:spPr>
-      </p:sp>
-      <p:sp>
-        <p:nvSpPr>
-          <p:cNvPr id="28" name="Text 25"/>
-          <p:cNvSpPr txBox="1"/>
-          <p:nvPr/>
-        </p:nvSpPr>
-        <p:spPr>
-          <a:xfrm>
-            <a:off x="8549640" y="4315968"/>
-            <a:ext cx="1005840" cy="457200"/>
-          </a:xfrm>
-          <a:prstGeom prst="rect">
-            <a:avLst/>
-          </a:prstGeom>
-          <a:noFill/>
-          <a:ln/>
-        </p:spPr>
-        <p:txBody>
-          <a:bodyPr wrap="square" lIns="0" tIns="0" rIns="0" bIns="0" rtlCol="0" anchor="ctr"/>
-          <a:lstStyle/>
-          <a:p>
-            <a:pPr indent="0" marL="0">
-              <a:buNone/>
-            </a:pPr>
-            <a:r>
-              <a:rPr lang="en-US" sz="1200" b="1" dirty="0">
-                <a:solidFill>
-                  <a:srgbClr val="0E1F0C"/>
-                </a:solidFill>
-                <a:latin typeface="Poppins" pitchFamily="34" charset="0"/>
-                <a:ea typeface="Poppins" pitchFamily="34" charset="-122"/>
-                <a:cs typeface="Poppins" pitchFamily="34" charset="-120"/>
-              </a:rPr>
-              <a:t>Highlights</a:t>
-            </a:r>
-            <a:endParaRPr lang="en-US" sz="1200" dirty="0"/>
-          </a:p>
-        </p:txBody>
-      </p:sp>
-      <p:sp>
-        <p:nvSpPr>
-          <p:cNvPr id="29" name="Text 26"/>
-          <p:cNvSpPr txBox="1"/>
-          <p:nvPr/>
-        </p:nvSpPr>
-        <p:spPr>
-          <a:xfrm>
-            <a:off x="8183880" y="5349240"/>
-            <a:ext cx="1737360" cy="365760"/>
-          </a:xfrm>
-          <a:prstGeom prst="rect">
-            <a:avLst/>
-          </a:prstGeom>
-          <a:noFill/>
-          <a:ln/>
-        </p:spPr>
-        <p:txBody>
-          <a:bodyPr wrap="square" lIns="0" tIns="0" rIns="0" bIns="0" rtlCol="0" anchor="t"/>
-          <a:lstStyle/>
-          <a:p>
-            <a:pPr algn="ctr" indent="0" marL="0">
-              <a:buNone/>
-            </a:pPr>
-            <a:r>
-              <a:rPr lang="en-US" sz="1600" b="1" dirty="0">
-                <a:solidFill>
-                  <a:srgbClr val="0E1F0C"/>
-                </a:solidFill>
-                <a:latin typeface="Poppins" pitchFamily="34" charset="0"/>
-                <a:ea typeface="Poppins" pitchFamily="34" charset="-122"/>
-                <a:cs typeface="Poppins" pitchFamily="34" charset="-120"/>
-              </a:rPr>
-              <a:t>Jonas’ Feed</a:t>
-            </a:r>
-            <a:endParaRPr lang="en-US" sz="1600" dirty="0"/>
-          </a:p>
-        </p:txBody>
-      </p:sp>
-      <p:sp>
-        <p:nvSpPr>
-          <p:cNvPr id="30" name="Shape 27"/>
-          <p:cNvSpPr/>
-          <p:nvPr/>
-        </p:nvSpPr>
-        <p:spPr>
-          <a:xfrm>
-            <a:off x="9966960" y="914400"/>
-            <a:ext cx="1554480" cy="4297680"/>
-          </a:xfrm>
-          <a:prstGeom prst="roundRect">
-            <a:avLst>
-              <a:gd name="adj" fmla="val 17647"/>
-            </a:avLst>
-          </a:prstGeom>
-          <a:solidFill>
-            <a:srgbClr val="12301A"/>
-          </a:solidFill>
-          <a:ln w="12700">
-            <a:solidFill>
-              <a:srgbClr val="12301A"/>
-            </a:solidFill>
-            <a:prstDash val="solid"/>
-          </a:ln>
-        </p:spPr>
-      </p:sp>
-      <p:sp>
-        <p:nvSpPr>
-          <p:cNvPr id="31" name="Shape 28"/>
-          <p:cNvSpPr/>
-          <p:nvPr/>
-        </p:nvSpPr>
-        <p:spPr>
-          <a:xfrm>
-            <a:off x="10058400" y="1005840"/>
-            <a:ext cx="1371600" cy="4114800"/>
-          </a:xfrm>
-          <a:prstGeom prst="roundRect">
-            <a:avLst>
-              <a:gd name="adj" fmla="val 14667"/>
-            </a:avLst>
-          </a:prstGeom>
-          <a:solidFill>
-            <a:srgbClr val="FBFFF4"/>
-          </a:solidFill>
-          <a:ln w="12700">
-            <a:solidFill>
-              <a:srgbClr val="FBFFF4"/>
-            </a:solidFill>
-            <a:prstDash val="solid"/>
-          </a:ln>
-        </p:spPr>
-      </p:sp>
-      <p:sp>
-        <p:nvSpPr>
-          <p:cNvPr id="32" name="Shape 29"/>
-          <p:cNvSpPr/>
-          <p:nvPr/>
-        </p:nvSpPr>
-        <p:spPr>
-          <a:xfrm>
-            <a:off x="10149840" y="1188720"/>
-            <a:ext cx="1188720" cy="1097280"/>
-          </a:xfrm>
-          <a:prstGeom prst="roundRect">
-            <a:avLst>
-              <a:gd name="adj" fmla="val 10000"/>
-            </a:avLst>
-          </a:prstGeom>
-          <a:solidFill>
-            <a:srgbClr val="B1FF37"/>
-          </a:solidFill>
-          <a:ln w="12700">
-            <a:solidFill>
-              <a:srgbClr val="B1FF37"/>
-            </a:solidFill>
-            <a:prstDash val="solid"/>
-          </a:ln>
-        </p:spPr>
-      </p:sp>
-      <p:sp>
-        <p:nvSpPr>
-          <p:cNvPr id="33" name="Text 30"/>
-          <p:cNvSpPr txBox="1"/>
-          <p:nvPr/>
-        </p:nvSpPr>
-        <p:spPr>
-          <a:xfrm>
-            <a:off x="10241280" y="1261872"/>
-            <a:ext cx="457200" cy="457200"/>
-          </a:xfrm>
-          <a:prstGeom prst="rect">
-            <a:avLst/>
-          </a:prstGeom>
-          <a:noFill/>
-          <a:ln/>
-        </p:spPr>
-        <p:txBody>
-          <a:bodyPr wrap="square" lIns="0" tIns="0" rIns="0" bIns="0" rtlCol="0" anchor="t"/>
-          <a:lstStyle/>
-          <a:p>
-            <a:pPr indent="0" marL="0">
-              <a:buNone/>
-            </a:pPr>
-            <a:r>
-              <a:rPr lang="en-US" sz="2200" b="1" dirty="0">
-                <a:solidFill>
-                  <a:srgbClr val="12301A"/>
-                </a:solidFill>
-                <a:latin typeface="Poppins" pitchFamily="34" charset="0"/>
-                <a:ea typeface="Poppins" pitchFamily="34" charset="-122"/>
-                <a:cs typeface="Poppins" pitchFamily="34" charset="-120"/>
-              </a:rPr>
-              <a:t>?</a:t>
-            </a:r>
-            <a:endParaRPr lang="en-US" sz="2200" dirty="0"/>
-          </a:p>
-        </p:txBody>
-      </p:sp>
-      <p:sp>
-        <p:nvSpPr>
-          <p:cNvPr id="34" name="Text 31"/>
-          <p:cNvSpPr txBox="1"/>
-          <p:nvPr/>
-        </p:nvSpPr>
-        <p:spPr>
-          <a:xfrm>
-            <a:off x="10241280" y="1755648"/>
-            <a:ext cx="1005840" cy="457200"/>
-          </a:xfrm>
-          <a:prstGeom prst="rect">
-            <a:avLst/>
-          </a:prstGeom>
-          <a:noFill/>
-          <a:ln/>
-        </p:spPr>
-        <p:txBody>
-          <a:bodyPr wrap="square" lIns="0" tIns="0" rIns="0" bIns="0" rtlCol="0" anchor="ctr"/>
-          <a:lstStyle/>
-          <a:p>
-            <a:pPr indent="0" marL="0">
-              <a:buNone/>
-            </a:pPr>
-            <a:r>
-              <a:rPr lang="en-US" sz="1200" b="1" dirty="0">
-                <a:solidFill>
-                  <a:srgbClr val="0E1F0C"/>
-                </a:solidFill>
-                <a:latin typeface="Poppins" pitchFamily="34" charset="0"/>
-                <a:ea typeface="Poppins" pitchFamily="34" charset="-122"/>
-                <a:cs typeface="Poppins" pitchFamily="34" charset="-120"/>
-              </a:rPr>
-              <a:t>Katzen?</a:t>
-            </a:r>
-            <a:endParaRPr lang="en-US" sz="1200" dirty="0"/>
-          </a:p>
-        </p:txBody>
-      </p:sp>
-      <p:sp>
-        <p:nvSpPr>
-          <p:cNvPr id="35" name="Shape 32"/>
-          <p:cNvSpPr/>
-          <p:nvPr/>
-        </p:nvSpPr>
-        <p:spPr>
-          <a:xfrm>
-            <a:off x="10149840" y="2468880"/>
-            <a:ext cx="1188720" cy="1097280"/>
-          </a:xfrm>
-          <a:prstGeom prst="roundRect">
-            <a:avLst>
-              <a:gd name="adj" fmla="val 10000"/>
-            </a:avLst>
-          </a:prstGeom>
-          <a:solidFill>
-            <a:srgbClr val="B1FF37"/>
-          </a:solidFill>
-          <a:ln w="12700">
-            <a:solidFill>
-              <a:srgbClr val="B1FF37"/>
-            </a:solidFill>
-            <a:prstDash val="solid"/>
-          </a:ln>
-        </p:spPr>
-      </p:sp>
-      <p:sp>
-        <p:nvSpPr>
-          <p:cNvPr id="36" name="Text 33"/>
-          <p:cNvSpPr txBox="1"/>
-          <p:nvPr/>
-        </p:nvSpPr>
-        <p:spPr>
-          <a:xfrm>
-            <a:off x="10241280" y="2542032"/>
-            <a:ext cx="457200" cy="457200"/>
-          </a:xfrm>
-          <a:prstGeom prst="rect">
-            <a:avLst/>
-          </a:prstGeom>
-          <a:noFill/>
-          <a:ln/>
-        </p:spPr>
-        <p:txBody>
-          <a:bodyPr wrap="square" lIns="0" tIns="0" rIns="0" bIns="0" rtlCol="0" anchor="t"/>
-          <a:lstStyle/>
-          <a:p>
-            <a:pPr indent="0" marL="0">
-              <a:buNone/>
-            </a:pPr>
-            <a:r>
-              <a:rPr lang="en-US" sz="2200" b="1" dirty="0">
-                <a:solidFill>
-                  <a:srgbClr val="12301A"/>
-                </a:solidFill>
-                <a:latin typeface="Poppins" pitchFamily="34" charset="0"/>
-                <a:ea typeface="Poppins" pitchFamily="34" charset="-122"/>
-                <a:cs typeface="Poppins" pitchFamily="34" charset="-120"/>
-              </a:rPr>
-              <a:t>?</a:t>
-            </a:r>
-            <a:endParaRPr lang="en-US" sz="2200" dirty="0"/>
-          </a:p>
-        </p:txBody>
-      </p:sp>
-      <p:sp>
-        <p:nvSpPr>
-          <p:cNvPr id="37" name="Text 34"/>
-          <p:cNvSpPr txBox="1"/>
-          <p:nvPr/>
-        </p:nvSpPr>
-        <p:spPr>
-          <a:xfrm>
-            <a:off x="10241280" y="3035808"/>
-            <a:ext cx="1005840" cy="457200"/>
-          </a:xfrm>
-          <a:prstGeom prst="rect">
-            <a:avLst/>
-          </a:prstGeom>
-          <a:noFill/>
-          <a:ln/>
-        </p:spPr>
-        <p:txBody>
-          <a:bodyPr wrap="square" lIns="0" tIns="0" rIns="0" bIns="0" rtlCol="0" anchor="ctr"/>
-          <a:lstStyle/>
-          <a:p>
-            <a:pPr indent="0" marL="0">
-              <a:buNone/>
-            </a:pPr>
-            <a:r>
-              <a:rPr lang="en-US" sz="1200" b="1" dirty="0">
-                <a:solidFill>
-                  <a:srgbClr val="0E1F0C"/>
-                </a:solidFill>
-                <a:latin typeface="Poppins" pitchFamily="34" charset="0"/>
-                <a:ea typeface="Poppins" pitchFamily="34" charset="-122"/>
-                <a:cs typeface="Poppins" pitchFamily="34" charset="-120"/>
-              </a:rPr>
-              <a:t>Minecraft?</a:t>
-            </a:r>
-            <a:endParaRPr lang="en-US" sz="1200" dirty="0"/>
-          </a:p>
-        </p:txBody>
-      </p:sp>
-      <p:sp>
-        <p:nvSpPr>
-          <p:cNvPr id="38" name="Shape 35"/>
-          <p:cNvSpPr/>
-          <p:nvPr/>
-        </p:nvSpPr>
-        <p:spPr>
-          <a:xfrm>
-            <a:off x="10149840" y="3749040"/>
-            <a:ext cx="1188720" cy="1097280"/>
-          </a:xfrm>
-          <a:prstGeom prst="roundRect">
-            <a:avLst>
-              <a:gd name="adj" fmla="val 10000"/>
-            </a:avLst>
-          </a:prstGeom>
-          <a:solidFill>
-            <a:srgbClr val="B1FF37"/>
-          </a:solidFill>
-          <a:ln w="12700">
-            <a:solidFill>
-              <a:srgbClr val="B1FF37"/>
-            </a:solidFill>
-            <a:prstDash val="solid"/>
-          </a:ln>
-        </p:spPr>
-      </p:sp>
-      <p:sp>
-        <p:nvSpPr>
-          <p:cNvPr id="39" name="Text 36"/>
-          <p:cNvSpPr txBox="1"/>
-          <p:nvPr/>
-        </p:nvSpPr>
-        <p:spPr>
-          <a:xfrm>
-            <a:off x="10241280" y="3822192"/>
-            <a:ext cx="457200" cy="457200"/>
-          </a:xfrm>
-          <a:prstGeom prst="rect">
-            <a:avLst/>
-          </a:prstGeom>
-          <a:noFill/>
-          <a:ln/>
-        </p:spPr>
-        <p:txBody>
-          <a:bodyPr wrap="square" lIns="0" tIns="0" rIns="0" bIns="0" rtlCol="0" anchor="t"/>
-          <a:lstStyle/>
-          <a:p>
-            <a:pPr indent="0" marL="0">
-              <a:buNone/>
-            </a:pPr>
-            <a:r>
-              <a:rPr lang="en-US" sz="2200" b="1" dirty="0">
-                <a:solidFill>
-                  <a:srgbClr val="12301A"/>
-                </a:solidFill>
-                <a:latin typeface="Poppins" pitchFamily="34" charset="0"/>
-                <a:ea typeface="Poppins" pitchFamily="34" charset="-122"/>
-                <a:cs typeface="Poppins" pitchFamily="34" charset="-120"/>
-              </a:rPr>
-              <a:t>?</a:t>
-            </a:r>
-            <a:endParaRPr lang="en-US" sz="2200" dirty="0"/>
-          </a:p>
-        </p:txBody>
-      </p:sp>
-      <p:sp>
-        <p:nvSpPr>
-          <p:cNvPr id="40" name="Text 37"/>
-          <p:cNvSpPr txBox="1"/>
-          <p:nvPr/>
-        </p:nvSpPr>
-        <p:spPr>
-          <a:xfrm>
-            <a:off x="10241280" y="4315968"/>
-            <a:ext cx="1005840" cy="457200"/>
-          </a:xfrm>
-          <a:prstGeom prst="rect">
-            <a:avLst/>
-          </a:prstGeom>
-          <a:noFill/>
-          <a:ln/>
-        </p:spPr>
-        <p:txBody>
-          <a:bodyPr wrap="square" lIns="0" tIns="0" rIns="0" bIns="0" rtlCol="0" anchor="ctr"/>
-          <a:lstStyle/>
-          <a:p>
-            <a:pPr indent="0" marL="0">
-              <a:buNone/>
-            </a:pPr>
-            <a:r>
-              <a:rPr lang="en-US" sz="1200" b="1" dirty="0">
-                <a:solidFill>
-                  <a:srgbClr val="0E1F0C"/>
-                </a:solidFill>
-                <a:latin typeface="Poppins" pitchFamily="34" charset="0"/>
-                <a:ea typeface="Poppins" pitchFamily="34" charset="-122"/>
-                <a:cs typeface="Poppins" pitchFamily="34" charset="-120"/>
-              </a:rPr>
-              <a:t>Kochen?</a:t>
-            </a:r>
-            <a:endParaRPr lang="en-US" sz="1200" dirty="0"/>
-          </a:p>
-        </p:txBody>
-      </p:sp>
-      <p:sp>
-        <p:nvSpPr>
-          <p:cNvPr id="41" name="Text 38"/>
-          <p:cNvSpPr txBox="1"/>
-          <p:nvPr/>
-        </p:nvSpPr>
-        <p:spPr>
-          <a:xfrm>
-            <a:off x="9875520" y="5349240"/>
-            <a:ext cx="1737360" cy="365760"/>
-          </a:xfrm>
-          <a:prstGeom prst="rect">
-            <a:avLst/>
-          </a:prstGeom>
-          <a:noFill/>
-          <a:ln/>
-        </p:spPr>
-        <p:txBody>
-          <a:bodyPr wrap="square" lIns="0" tIns="0" rIns="0" bIns="0" rtlCol="0" anchor="t"/>
-          <a:lstStyle/>
-          <a:p>
-            <a:pPr algn="ctr" indent="0" marL="0">
-              <a:buNone/>
-            </a:pPr>
-            <a:r>
-              <a:rPr lang="en-US" sz="1600" b="1" dirty="0">
-                <a:solidFill>
-                  <a:srgbClr val="26720A"/>
-                </a:solidFill>
-                <a:latin typeface="Poppins" pitchFamily="34" charset="0"/>
-                <a:ea typeface="Poppins" pitchFamily="34" charset="-122"/>
-                <a:cs typeface="Poppins" pitchFamily="34" charset="-120"/>
-              </a:rPr>
-              <a:t>Dein Feed</a:t>
-            </a:r>
-            <a:endParaRPr lang="en-US" sz="1600" dirty="0"/>
+              <a:t>Kochrezepte?</a:t>
+            </a:r>
+            <a:endParaRPr lang="en-US" sz="1700" dirty="0"/>
           </a:p>
         </p:txBody>
       </p:sp>

</xml_diff>